<commit_message>
docs(rap-deck): add 'skill example' slide rendering activating-objects
Manager feedback on the deck: show what one skill actually looks like,
not just the catalog. Inserts a slide between the catalog and the
artifacts-across-phases comparison, rendering the activating-objects.md
skill's front-matter + hard rules + common-error fixes in two columns.

12 slides total now.

Co-Authored-By: Claude Opus 4.7 (1M context) <noreply@anthropic.com>
</commit_message>
<xml_diff>
--- a/docs/tutorials/rap-bo-book-catalog/examples/book-catalog/report.simple-deck.pptx
+++ b/docs/tutorials/rap-bo-book-catalog/examples/book-catalog/report.simple-deck.pptx
@@ -22,6 +22,7 @@
     <p:sldId id="264" r:id="rId21"/>
     <p:sldId id="265" r:id="rId22"/>
     <p:sldId id="266" r:id="rId23"/>
+    <p:sldId id="267" r:id="rId24"/>
   </p:sldIdLst>
   <p:sldSz cx="12192000" cy="6858000"/>
   <p:notesSz cx="6858000" cy="9144000"/>
@@ -34203,7 +34204,7 @@
           <a:lstStyle/>
           <a:p>
             <a:r>
-              <a:t>Two failure modes · how to catch them</a:t>
+              <a:t>What got built · 72 objects, all active</a:t>
             </a:r>
           </a:p>
         </p:txBody>
@@ -34224,7 +34225,7 @@
           <a:lstStyle/>
           <a:p>
             <a:r>
-              <a:t>DRIFT · HALLUCINATION</a:t>
+              <a:t>4 ENTITIES · 1 RAP APP</a:t>
             </a:r>
           </a:p>
         </p:txBody>
@@ -34272,14 +34273,724 @@
       </p:sp>
       <p:sp>
         <p:nvSpPr>
-          <p:cNvPr id="5" name="c_1_BlockGrid:0:c_1_Block"/>
+          <p:cNvPr id="5" name="c_1_BlockGrid:0:c_1_Block:container"/>
           <p:cNvSpPr/>
           <p:nvPr/>
         </p:nvSpPr>
         <p:spPr>
           <a:xfrm>
             <a:off x="457200" y="1463040"/>
-            <a:ext cx="3566160" cy="4663440"/>
+            <a:ext cx="2697480" cy="1554480"/>
+          </a:xfrm>
+          <a:prstGeom prst="rect">
+            <a:avLst/>
+          </a:prstGeom>
+          <a:noFill/>
+          <a:ln>
+            <a:noFill/>
+          </a:ln>
+        </p:spPr>
+        <p:style>
+          <a:lnRef idx="1">
+            <a:schemeClr val="accent1"/>
+          </a:lnRef>
+          <a:fillRef idx="3">
+            <a:schemeClr val="accent1"/>
+          </a:fillRef>
+          <a:effectRef idx="2">
+            <a:schemeClr val="accent1"/>
+          </a:effectRef>
+          <a:fontRef idx="minor">
+            <a:schemeClr val="lt1"/>
+          </a:fontRef>
+        </p:style>
+        <p:txBody>
+          <a:bodyPr rtlCol="0" anchor="ctr"/>
+          <a:lstStyle/>
+          <a:p>
+            <a:pPr algn="ctr"/>
+          </a:p>
+        </p:txBody>
+      </p:sp>
+      <p:sp>
+        <p:nvSpPr>
+          <p:cNvPr id="6" name="c_1_BlockGrid:0:c_1_Block:metric"/>
+          <p:cNvSpPr txBox="1"/>
+          <p:nvPr/>
+        </p:nvSpPr>
+        <p:spPr>
+          <a:xfrm>
+            <a:off x="640080" y="1600200"/>
+            <a:ext cx="2331720" cy="408939"/>
+          </a:xfrm>
+          <a:prstGeom prst="rect">
+            <a:avLst/>
+          </a:prstGeom>
+          <a:noFill/>
+        </p:spPr>
+        <p:txBody>
+          <a:bodyPr wrap="none" lIns="0" rIns="0" tIns="0" bIns="0">
+            <a:spAutoFit/>
+          </a:bodyPr>
+          <a:lstStyle/>
+          <a:p>
+            <a:pPr algn="ctr"/>
+            <a:r>
+              <a:rPr sz="2800" b="1">
+                <a:solidFill>
+                  <a:srgbClr val="107E8D"/>
+                </a:solidFill>
+              </a:rPr>
+              <a:t>72</a:t>
+            </a:r>
+          </a:p>
+        </p:txBody>
+      </p:sp>
+      <p:sp>
+        <p:nvSpPr>
+          <p:cNvPr id="7" name="c_1_BlockGrid:0:c_1_Block:content"/>
+          <p:cNvSpPr txBox="1"/>
+          <p:nvPr/>
+        </p:nvSpPr>
+        <p:spPr>
+          <a:xfrm>
+            <a:off x="640080" y="2077719"/>
+            <a:ext cx="2331720" cy="219074"/>
+          </a:xfrm>
+          <a:prstGeom prst="rect">
+            <a:avLst/>
+          </a:prstGeom>
+          <a:noFill/>
+        </p:spPr>
+        <p:txBody>
+          <a:bodyPr wrap="square" lIns="0" rIns="0" tIns="0" bIns="0" anchor="t"/>
+          <a:lstStyle/>
+          <a:p>
+            <a:pPr algn="ctr"/>
+            <a:r>
+              <a:rPr sz="1400">
+                <a:solidFill>
+                  <a:srgbClr val="000000"/>
+                </a:solidFill>
+              </a:rPr>
+              <a:t>objects active</a:t>
+            </a:r>
+          </a:p>
+        </p:txBody>
+      </p:sp>
+      <p:sp>
+        <p:nvSpPr>
+          <p:cNvPr id="8" name="c_1_BlockGrid:1:c_2_Block:container"/>
+          <p:cNvSpPr/>
+          <p:nvPr/>
+        </p:nvSpPr>
+        <p:spPr>
+          <a:xfrm>
+            <a:off x="3246120" y="1463040"/>
+            <a:ext cx="2697480" cy="1554480"/>
+          </a:xfrm>
+          <a:prstGeom prst="rect">
+            <a:avLst/>
+          </a:prstGeom>
+          <a:noFill/>
+          <a:ln>
+            <a:noFill/>
+          </a:ln>
+        </p:spPr>
+        <p:style>
+          <a:lnRef idx="1">
+            <a:schemeClr val="accent1"/>
+          </a:lnRef>
+          <a:fillRef idx="3">
+            <a:schemeClr val="accent1"/>
+          </a:fillRef>
+          <a:effectRef idx="2">
+            <a:schemeClr val="accent1"/>
+          </a:effectRef>
+          <a:fontRef idx="minor">
+            <a:schemeClr val="lt1"/>
+          </a:fontRef>
+        </p:style>
+        <p:txBody>
+          <a:bodyPr rtlCol="0" anchor="ctr"/>
+          <a:lstStyle/>
+          <a:p>
+            <a:pPr algn="ctr"/>
+          </a:p>
+        </p:txBody>
+      </p:sp>
+      <p:sp>
+        <p:nvSpPr>
+          <p:cNvPr id="9" name="c_1_BlockGrid:1:c_2_Block:metric"/>
+          <p:cNvSpPr txBox="1"/>
+          <p:nvPr/>
+        </p:nvSpPr>
+        <p:spPr>
+          <a:xfrm>
+            <a:off x="3429000" y="1600200"/>
+            <a:ext cx="2331720" cy="408939"/>
+          </a:xfrm>
+          <a:prstGeom prst="rect">
+            <a:avLst/>
+          </a:prstGeom>
+          <a:noFill/>
+        </p:spPr>
+        <p:txBody>
+          <a:bodyPr wrap="none" lIns="0" rIns="0" tIns="0" bIns="0">
+            <a:spAutoFit/>
+          </a:bodyPr>
+          <a:lstStyle/>
+          <a:p>
+            <a:pPr algn="ctr"/>
+            <a:r>
+              <a:rPr sz="2800" b="1">
+                <a:solidFill>
+                  <a:srgbClr val="0047FF"/>
+                </a:solidFill>
+              </a:rPr>
+              <a:t>77</a:t>
+            </a:r>
+          </a:p>
+        </p:txBody>
+      </p:sp>
+      <p:sp>
+        <p:nvSpPr>
+          <p:cNvPr id="10" name="c_1_BlockGrid:1:c_2_Block:content"/>
+          <p:cNvSpPr txBox="1"/>
+          <p:nvPr/>
+        </p:nvSpPr>
+        <p:spPr>
+          <a:xfrm>
+            <a:off x="3429000" y="2077719"/>
+            <a:ext cx="2331720" cy="219074"/>
+          </a:xfrm>
+          <a:prstGeom prst="rect">
+            <a:avLst/>
+          </a:prstGeom>
+          <a:noFill/>
+        </p:spPr>
+        <p:txBody>
+          <a:bodyPr wrap="square" lIns="0" rIns="0" tIns="0" bIns="0" anchor="t"/>
+          <a:lstStyle/>
+          <a:p>
+            <a:pPr algn="ctr"/>
+            <a:r>
+              <a:rPr sz="1400">
+                <a:solidFill>
+                  <a:srgbClr val="000000"/>
+                </a:solidFill>
+              </a:rPr>
+              <a:t>API prompts in P4</a:t>
+            </a:r>
+          </a:p>
+        </p:txBody>
+      </p:sp>
+      <p:sp>
+        <p:nvSpPr>
+          <p:cNvPr id="11" name="c_1_BlockGrid:2:c_3_Block:container"/>
+          <p:cNvSpPr/>
+          <p:nvPr/>
+        </p:nvSpPr>
+        <p:spPr>
+          <a:xfrm>
+            <a:off x="6035040" y="1463040"/>
+            <a:ext cx="2697480" cy="1554480"/>
+          </a:xfrm>
+          <a:prstGeom prst="rect">
+            <a:avLst/>
+          </a:prstGeom>
+          <a:noFill/>
+          <a:ln>
+            <a:noFill/>
+          </a:ln>
+        </p:spPr>
+        <p:style>
+          <a:lnRef idx="1">
+            <a:schemeClr val="accent1"/>
+          </a:lnRef>
+          <a:fillRef idx="3">
+            <a:schemeClr val="accent1"/>
+          </a:fillRef>
+          <a:effectRef idx="2">
+            <a:schemeClr val="accent1"/>
+          </a:effectRef>
+          <a:fontRef idx="minor">
+            <a:schemeClr val="lt1"/>
+          </a:fontRef>
+        </p:style>
+        <p:txBody>
+          <a:bodyPr rtlCol="0" anchor="ctr"/>
+          <a:lstStyle/>
+          <a:p>
+            <a:pPr algn="ctr"/>
+          </a:p>
+        </p:txBody>
+      </p:sp>
+      <p:sp>
+        <p:nvSpPr>
+          <p:cNvPr id="12" name="c_1_BlockGrid:2:c_3_Block:metric"/>
+          <p:cNvSpPr txBox="1"/>
+          <p:nvPr/>
+        </p:nvSpPr>
+        <p:spPr>
+          <a:xfrm>
+            <a:off x="6217920" y="1600200"/>
+            <a:ext cx="2331720" cy="408939"/>
+          </a:xfrm>
+          <a:prstGeom prst="rect">
+            <a:avLst/>
+          </a:prstGeom>
+          <a:noFill/>
+        </p:spPr>
+        <p:txBody>
+          <a:bodyPr wrap="none" lIns="0" rIns="0" tIns="0" bIns="0">
+            <a:spAutoFit/>
+          </a:bodyPr>
+          <a:lstStyle/>
+          <a:p>
+            <a:pPr algn="ctr"/>
+            <a:r>
+              <a:rPr sz="2800" b="1">
+                <a:solidFill>
+                  <a:srgbClr val="E06C00"/>
+                </a:solidFill>
+              </a:rPr>
+              <a:t>~$19</a:t>
+            </a:r>
+          </a:p>
+        </p:txBody>
+      </p:sp>
+      <p:sp>
+        <p:nvSpPr>
+          <p:cNvPr id="13" name="c_1_BlockGrid:2:c_3_Block:content"/>
+          <p:cNvSpPr txBox="1"/>
+          <p:nvPr/>
+        </p:nvSpPr>
+        <p:spPr>
+          <a:xfrm>
+            <a:off x="6217920" y="2077719"/>
+            <a:ext cx="2331720" cy="219074"/>
+          </a:xfrm>
+          <a:prstGeom prst="rect">
+            <a:avLst/>
+          </a:prstGeom>
+          <a:noFill/>
+        </p:spPr>
+        <p:txBody>
+          <a:bodyPr wrap="square" lIns="0" rIns="0" tIns="0" bIns="0" anchor="t"/>
+          <a:lstStyle/>
+          <a:p>
+            <a:pPr algn="ctr"/>
+            <a:r>
+              <a:rPr sz="1400">
+                <a:solidFill>
+                  <a:srgbClr val="000000"/>
+                </a:solidFill>
+              </a:rPr>
+              <a:t>API cost · vs ~$2k manual</a:t>
+            </a:r>
+          </a:p>
+        </p:txBody>
+      </p:sp>
+      <p:sp>
+        <p:nvSpPr>
+          <p:cNvPr id="14" name="c_1_BlockGrid:3:c_4_Block:container"/>
+          <p:cNvSpPr/>
+          <p:nvPr/>
+        </p:nvSpPr>
+        <p:spPr>
+          <a:xfrm>
+            <a:off x="8823960" y="1463040"/>
+            <a:ext cx="2697480" cy="1554480"/>
+          </a:xfrm>
+          <a:prstGeom prst="rect">
+            <a:avLst/>
+          </a:prstGeom>
+          <a:noFill/>
+          <a:ln>
+            <a:noFill/>
+          </a:ln>
+        </p:spPr>
+        <p:style>
+          <a:lnRef idx="1">
+            <a:schemeClr val="accent1"/>
+          </a:lnRef>
+          <a:fillRef idx="3">
+            <a:schemeClr val="accent1"/>
+          </a:fillRef>
+          <a:effectRef idx="2">
+            <a:schemeClr val="accent1"/>
+          </a:effectRef>
+          <a:fontRef idx="minor">
+            <a:schemeClr val="lt1"/>
+          </a:fontRef>
+        </p:style>
+        <p:txBody>
+          <a:bodyPr rtlCol="0" anchor="ctr"/>
+          <a:lstStyle/>
+          <a:p>
+            <a:pPr algn="ctr"/>
+          </a:p>
+        </p:txBody>
+      </p:sp>
+      <p:sp>
+        <p:nvSpPr>
+          <p:cNvPr id="15" name="c_1_BlockGrid:3:c_4_Block:metric"/>
+          <p:cNvSpPr txBox="1"/>
+          <p:nvPr/>
+        </p:nvSpPr>
+        <p:spPr>
+          <a:xfrm>
+            <a:off x="9006840" y="1600200"/>
+            <a:ext cx="2331720" cy="408939"/>
+          </a:xfrm>
+          <a:prstGeom prst="rect">
+            <a:avLst/>
+          </a:prstGeom>
+          <a:noFill/>
+        </p:spPr>
+        <p:txBody>
+          <a:bodyPr wrap="none" lIns="0" rIns="0" tIns="0" bIns="0">
+            <a:spAutoFit/>
+          </a:bodyPr>
+          <a:lstStyle/>
+          <a:p>
+            <a:pPr algn="ctr"/>
+            <a:r>
+              <a:rPr sz="2800" b="1">
+                <a:solidFill>
+                  <a:srgbClr val="E614EB"/>
+                </a:solidFill>
+              </a:rPr>
+              <a:t>~3h</a:t>
+            </a:r>
+          </a:p>
+        </p:txBody>
+      </p:sp>
+      <p:sp>
+        <p:nvSpPr>
+          <p:cNvPr id="16" name="c_1_BlockGrid:3:c_4_Block:content"/>
+          <p:cNvSpPr txBox="1"/>
+          <p:nvPr/>
+        </p:nvSpPr>
+        <p:spPr>
+          <a:xfrm>
+            <a:off x="9006840" y="2077719"/>
+            <a:ext cx="2331720" cy="219074"/>
+          </a:xfrm>
+          <a:prstGeom prst="rect">
+            <a:avLst/>
+          </a:prstGeom>
+          <a:noFill/>
+        </p:spPr>
+        <p:txBody>
+          <a:bodyPr wrap="square" lIns="0" rIns="0" tIns="0" bIns="0" anchor="t"/>
+          <a:lstStyle/>
+          <a:p>
+            <a:pPr algn="ctr"/>
+            <a:r>
+              <a:rPr sz="1400">
+                <a:solidFill>
+                  <a:srgbClr val="000000"/>
+                </a:solidFill>
+              </a:rPr>
+              <a:t>wall-clock · vs ~2 weeks</a:t>
+            </a:r>
+          </a:p>
+        </p:txBody>
+      </p:sp>
+      <p:sp>
+        <p:nvSpPr>
+          <p:cNvPr id="17" name="c_2_BlockGrid:0:c_5_Block"/>
+          <p:cNvSpPr/>
+          <p:nvPr/>
+        </p:nvSpPr>
+        <p:spPr>
+          <a:xfrm>
+            <a:off x="457200" y="3200400"/>
+            <a:ext cx="3566160" cy="2926080"/>
+          </a:xfrm>
+          <a:prstGeom prst="rect">
+            <a:avLst/>
+          </a:prstGeom>
+          <a:gradFill rotWithShape="1">
+            <a:gsLst>
+              <a:gs pos="0">
+                <a:srgbClr val="003FE5"/>
+              </a:gs>
+              <a:gs pos="100000">
+                <a:srgbClr val="1959FF"/>
+              </a:gs>
+            </a:gsLst>
+            <a:lin ang="16200000" scaled="0"/>
+          </a:gradFill>
+          <a:ln w="3175">
+            <a:solidFill>
+              <a:srgbClr val="4B5366"/>
+            </a:solidFill>
+          </a:ln>
+        </p:spPr>
+        <p:style>
+          <a:lnRef idx="1">
+            <a:schemeClr val="accent1"/>
+          </a:lnRef>
+          <a:fillRef idx="3">
+            <a:schemeClr val="accent1"/>
+          </a:fillRef>
+          <a:effectRef idx="2">
+            <a:schemeClr val="accent1"/>
+          </a:effectRef>
+          <a:fontRef idx="minor">
+            <a:schemeClr val="lt1"/>
+          </a:fontRef>
+        </p:style>
+        <p:txBody>
+          <a:bodyPr rtlCol="0" anchor="t" wrap="square" tIns="91440" bIns="91440"/>
+          <a:lstStyle/>
+          <a:p>
+            <a:pPr algn="l">
+              <a:spcAft>
+                <a:spcPts val="500"/>
+              </a:spcAft>
+            </a:pPr>
+            <a:r>
+              <a:rPr sz="1400" b="1">
+                <a:solidFill>
+                  <a:srgbClr val="FFFFFF"/>
+                </a:solidFill>
+              </a:rPr>
+              <a:t>DDIC layer</a:t>
+            </a:r>
+          </a:p>
+          <a:p>
+            <a:pPr algn="l" marL="228600" indent="-182880">
+              <a:spcAft>
+                <a:spcPts val="0"/>
+              </a:spcAft>
+              <a:buClr>
+                <a:srgbClr val="FFFFFF"/>
+              </a:buClr>
+              <a:buChar char="•"/>
+            </a:pPr>
+            <a:r>
+              <a:rPr sz="1100">
+                <a:solidFill>
+                  <a:srgbClr val="FFFFFF"/>
+                </a:solidFill>
+              </a:rPr>
+              <a:t>20 domains (DOMA)</a:t>
+            </a:r>
+          </a:p>
+          <a:p>
+            <a:pPr algn="l" marL="228600" indent="-182880">
+              <a:spcAft>
+                <a:spcPts val="0"/>
+              </a:spcAft>
+              <a:buClr>
+                <a:srgbClr val="FFFFFF"/>
+              </a:buClr>
+              <a:buChar char="•"/>
+            </a:pPr>
+            <a:r>
+              <a:rPr sz="1100">
+                <a:solidFill>
+                  <a:srgbClr val="FFFFFF"/>
+                </a:solidFill>
+              </a:rPr>
+              <a:t>20 data elements (DTEL)</a:t>
+            </a:r>
+          </a:p>
+          <a:p>
+            <a:pPr algn="l" marL="228600" indent="-182880">
+              <a:spcAft>
+                <a:spcPts val="0"/>
+              </a:spcAft>
+              <a:buClr>
+                <a:srgbClr val="FFFFFF"/>
+              </a:buClr>
+              <a:buChar char="•"/>
+            </a:pPr>
+            <a:r>
+              <a:rPr sz="1100">
+                <a:solidFill>
+                  <a:srgbClr val="FFFFFF"/>
+                </a:solidFill>
+              </a:rPr>
+              <a:t>4 persistent tables (TABL)</a:t>
+            </a:r>
+          </a:p>
+          <a:p>
+            <a:pPr algn="l" marL="228600" indent="-182880">
+              <a:spcAft>
+                <a:spcPts val="0"/>
+              </a:spcAft>
+              <a:buClr>
+                <a:srgbClr val="FFFFFF"/>
+              </a:buClr>
+              <a:buChar char="•"/>
+            </a:pPr>
+            <a:r>
+              <a:rPr sz="1100">
+                <a:solidFill>
+                  <a:srgbClr val="FFFFFF"/>
+                </a:solidFill>
+              </a:rPr>
+              <a:t>4 draft tables (TABL _D)</a:t>
+            </a:r>
+          </a:p>
+        </p:txBody>
+      </p:sp>
+      <p:sp>
+        <p:nvSpPr>
+          <p:cNvPr id="18" name="c_2_BlockGrid:1:c_6_Block"/>
+          <p:cNvSpPr/>
+          <p:nvPr/>
+        </p:nvSpPr>
+        <p:spPr>
+          <a:xfrm>
+            <a:off x="4206240" y="3200400"/>
+            <a:ext cx="3566160" cy="2926080"/>
+          </a:xfrm>
+          <a:prstGeom prst="rect">
+            <a:avLst/>
+          </a:prstGeom>
+          <a:gradFill rotWithShape="1">
+            <a:gsLst>
+              <a:gs pos="0">
+                <a:srgbClr val="0D6976"/>
+              </a:gs>
+              <a:gs pos="100000">
+                <a:srgbClr val="1292A3"/>
+              </a:gs>
+            </a:gsLst>
+            <a:lin ang="16200000" scaled="0"/>
+          </a:gradFill>
+          <a:ln w="3175">
+            <a:solidFill>
+              <a:srgbClr val="303B3D"/>
+            </a:solidFill>
+          </a:ln>
+        </p:spPr>
+        <p:style>
+          <a:lnRef idx="1">
+            <a:schemeClr val="accent1"/>
+          </a:lnRef>
+          <a:fillRef idx="3">
+            <a:schemeClr val="accent1"/>
+          </a:fillRef>
+          <a:effectRef idx="2">
+            <a:schemeClr val="accent1"/>
+          </a:effectRef>
+          <a:fontRef idx="minor">
+            <a:schemeClr val="lt1"/>
+          </a:fontRef>
+        </p:style>
+        <p:txBody>
+          <a:bodyPr rtlCol="0" anchor="t" wrap="square" tIns="91440" bIns="91440"/>
+          <a:lstStyle/>
+          <a:p>
+            <a:pPr algn="l">
+              <a:spcAft>
+                <a:spcPts val="500"/>
+              </a:spcAft>
+            </a:pPr>
+            <a:r>
+              <a:rPr sz="1400" b="1">
+                <a:solidFill>
+                  <a:srgbClr val="FFFFFF"/>
+                </a:solidFill>
+              </a:rPr>
+              <a:t>RAP layer</a:t>
+            </a:r>
+          </a:p>
+          <a:p>
+            <a:pPr algn="l" marL="228600" indent="-182880">
+              <a:spcAft>
+                <a:spcPts val="0"/>
+              </a:spcAft>
+              <a:buClr>
+                <a:srgbClr val="FFFFFF"/>
+              </a:buClr>
+              <a:buChar char="•"/>
+            </a:pPr>
+            <a:r>
+              <a:rPr sz="1100">
+                <a:solidFill>
+                  <a:srgbClr val="FFFFFF"/>
+                </a:solidFill>
+              </a:rPr>
+              <a:t>4 interface CDS (Z##_R_*)</a:t>
+            </a:r>
+          </a:p>
+          <a:p>
+            <a:pPr algn="l" marL="228600" indent="-182880">
+              <a:spcAft>
+                <a:spcPts val="0"/>
+              </a:spcAft>
+              <a:buClr>
+                <a:srgbClr val="FFFFFF"/>
+              </a:buClr>
+              <a:buChar char="•"/>
+            </a:pPr>
+            <a:r>
+              <a:rPr sz="1100">
+                <a:solidFill>
+                  <a:srgbClr val="FFFFFF"/>
+                </a:solidFill>
+              </a:rPr>
+              <a:t>4 projection CDS (Z##_C_*)</a:t>
+            </a:r>
+          </a:p>
+          <a:p>
+            <a:pPr algn="l" marL="228600" indent="-182880">
+              <a:spcAft>
+                <a:spcPts val="0"/>
+              </a:spcAft>
+              <a:buClr>
+                <a:srgbClr val="FFFFFF"/>
+              </a:buClr>
+              <a:buChar char="•"/>
+            </a:pPr>
+            <a:r>
+              <a:rPr sz="1100">
+                <a:solidFill>
+                  <a:srgbClr val="FFFFFF"/>
+                </a:solidFill>
+              </a:rPr>
+              <a:t>4 metadata extensions</a:t>
+            </a:r>
+          </a:p>
+          <a:p>
+            <a:pPr algn="l" marL="228600" indent="-182880">
+              <a:spcAft>
+                <a:spcPts val="0"/>
+              </a:spcAft>
+              <a:buClr>
+                <a:srgbClr val="FFFFFF"/>
+              </a:buClr>
+              <a:buChar char="•"/>
+            </a:pPr>
+            <a:r>
+              <a:rPr sz="1100">
+                <a:solidFill>
+                  <a:srgbClr val="FFFFFF"/>
+                </a:solidFill>
+              </a:rPr>
+              <a:t>4 BDEF + 4 BIMP classes</a:t>
+            </a:r>
+          </a:p>
+        </p:txBody>
+      </p:sp>
+      <p:sp>
+        <p:nvSpPr>
+          <p:cNvPr id="19" name="c_2_BlockGrid:2:c_7_Block"/>
+          <p:cNvSpPr/>
+          <p:nvPr/>
+        </p:nvSpPr>
+        <p:spPr>
+          <a:xfrm>
+            <a:off x="7955280" y="3200400"/>
+            <a:ext cx="3566160" cy="2926080"/>
           </a:xfrm>
           <a:prstGeom prst="rect">
             <a:avLst/>
@@ -34330,275 +35041,83 @@
                   <a:srgbClr val="000000"/>
                 </a:solidFill>
               </a:rPr>
-              <a:t>Spec / plan drift</a:t>
-            </a:r>
-          </a:p>
-          <a:p>
-            <a:pPr algn="l">
+              <a:t>Service · UI</a:t>
+            </a:r>
+          </a:p>
+          <a:p>
+            <a:pPr algn="l" marL="228600" indent="-182880">
               <a:spcAft>
                 <a:spcPts val="0"/>
               </a:spcAft>
+              <a:buClr>
+                <a:srgbClr val="000000"/>
+              </a:buClr>
+              <a:buChar char="•"/>
             </a:pPr>
             <a:r>
-              <a:rPr sz="1400" b="1">
+              <a:rPr sz="1100">
                 <a:solidFill>
                   <a:srgbClr val="000000"/>
                 </a:solidFill>
               </a:rPr>
-              <a:t>Symptom: </a:t>
-            </a:r>
-            <a:r>
-              <a:rPr sz="1400">
-                <a:solidFill>
-                  <a:srgbClr val="000000"/>
-                </a:solidFill>
-              </a:rPr>
-              <a:t>extra objects, missing ones, silent renames.</a:t>
-            </a:r>
-          </a:p>
-          <a:p>
-            <a:pPr algn="l">
+              <a:t>1 service definition</a:t>
+            </a:r>
+          </a:p>
+          <a:p>
+            <a:pPr algn="l" marL="228600" indent="-182880">
               <a:spcAft>
                 <a:spcPts val="0"/>
               </a:spcAft>
+              <a:buClr>
+                <a:srgbClr val="000000"/>
+              </a:buClr>
+              <a:buChar char="•"/>
             </a:pPr>
             <a:r>
-              <a:rPr sz="1400" b="1">
+              <a:rPr sz="1100">
                 <a:solidFill>
                   <a:srgbClr val="000000"/>
                 </a:solidFill>
               </a:rPr>
-              <a:t>Catch: </a:t>
-            </a:r>
-            <a:r>
-              <a:rPr sz="1400">
-                <a:solidFill>
-                  <a:srgbClr val="000000"/>
-                </a:solidFill>
-              </a:rPr>
-              <a:t>quote the plan back; force exact list.</a:t>
-            </a:r>
-          </a:p>
-        </p:txBody>
-      </p:sp>
-      <p:sp>
-        <p:nvSpPr>
-          <p:cNvPr id="6" name="c_1_BlockGrid:1:c_2_Block"/>
-          <p:cNvSpPr/>
-          <p:nvPr/>
-        </p:nvSpPr>
-        <p:spPr>
-          <a:xfrm>
-            <a:off x="4206240" y="1463040"/>
-            <a:ext cx="3566160" cy="4663440"/>
-          </a:xfrm>
-          <a:prstGeom prst="rect">
-            <a:avLst/>
-          </a:prstGeom>
-          <a:gradFill rotWithShape="1">
-            <a:gsLst>
-              <a:gs pos="0">
-                <a:srgbClr val="CE0101"/>
-              </a:gs>
-              <a:gs pos="100000">
-                <a:srgbClr val="FC0606"/>
-              </a:gs>
-            </a:gsLst>
-            <a:lin ang="16200000" scaled="0"/>
-          </a:gradFill>
-          <a:ln w="3175">
-            <a:solidFill>
-              <a:srgbClr val="5D4545"/>
-            </a:solidFill>
-          </a:ln>
-        </p:spPr>
-        <p:style>
-          <a:lnRef idx="1">
-            <a:schemeClr val="accent1"/>
-          </a:lnRef>
-          <a:fillRef idx="3">
-            <a:schemeClr val="accent1"/>
-          </a:fillRef>
-          <a:effectRef idx="2">
-            <a:schemeClr val="accent1"/>
-          </a:effectRef>
-          <a:fontRef idx="minor">
-            <a:schemeClr val="lt1"/>
-          </a:fontRef>
-        </p:style>
-        <p:txBody>
-          <a:bodyPr rtlCol="0" anchor="t" wrap="square" tIns="91440" bIns="91440"/>
-          <a:lstStyle/>
-          <a:p>
-            <a:pPr algn="l">
-              <a:spcAft>
-                <a:spcPts val="500"/>
-              </a:spcAft>
-            </a:pPr>
-            <a:r>
-              <a:rPr sz="1400" b="1">
-                <a:solidFill>
-                  <a:srgbClr val="FFFFFF"/>
-                </a:solidFill>
-              </a:rPr>
-              <a:t>Hallucination</a:t>
-            </a:r>
-          </a:p>
-          <a:p>
-            <a:pPr algn="l">
+              <a:t>1 OData V4 binding (published)</a:t>
+            </a:r>
+          </a:p>
+          <a:p>
+            <a:pPr algn="l" marL="228600" indent="-182880">
               <a:spcAft>
                 <a:spcPts val="0"/>
               </a:spcAft>
+              <a:buClr>
+                <a:srgbClr val="000000"/>
+              </a:buClr>
+              <a:buChar char="•"/>
             </a:pPr>
             <a:r>
-              <a:rPr sz="1400" b="1">
-                <a:solidFill>
-                  <a:srgbClr val="FFFFFF"/>
+              <a:rPr sz="1100">
+                <a:solidFill>
+                  <a:srgbClr val="000000"/>
                 </a:solidFill>
               </a:rPr>
-              <a:t>Symptom: </a:t>
-            </a:r>
-            <a:r>
-              <a:rPr sz="1400">
-                <a:solidFill>
-                  <a:srgbClr val="FFFFFF"/>
-                </a:solidFill>
-              </a:rPr>
-              <a:t>"All N active" with no Executing trace.</a:t>
-            </a:r>
-          </a:p>
-          <a:p>
-            <a:pPr algn="l">
+              <a:t>Fiori Elements preview · CRUD + draft</a:t>
+            </a:r>
+          </a:p>
+          <a:p>
+            <a:pPr algn="l" marL="228600" indent="-182880">
               <a:spcAft>
                 <a:spcPts val="0"/>
               </a:spcAft>
+              <a:buClr>
+                <a:srgbClr val="000000"/>
+              </a:buClr>
+              <a:buChar char="•"/>
             </a:pPr>
             <a:r>
-              <a:rPr sz="1400" b="1">
-                <a:solidFill>
-                  <a:srgbClr val="FFFFFF"/>
+              <a:rPr sz="1100">
+                <a:solidFill>
+                  <a:srgbClr val="000000"/>
                 </a:solidFill>
               </a:rPr>
-              <a:t>Catch: </a:t>
-            </a:r>
-            <a:r>
-              <a:rPr sz="1400">
-                <a:solidFill>
-                  <a:srgbClr val="FFFFFF"/>
-                </a:solidFill>
-              </a:rPr>
-              <a:t>low token count · ask agent to read each object back.</a:t>
-            </a:r>
-          </a:p>
-        </p:txBody>
-      </p:sp>
-      <p:sp>
-        <p:nvSpPr>
-          <p:cNvPr id="7" name="c_1_BlockGrid:2:c_3_Block"/>
-          <p:cNvSpPr/>
-          <p:nvPr/>
-        </p:nvSpPr>
-        <p:spPr>
-          <a:xfrm>
-            <a:off x="7955280" y="1463040"/>
-            <a:ext cx="3566160" cy="4663440"/>
-          </a:xfrm>
-          <a:prstGeom prst="rect">
-            <a:avLst/>
-          </a:prstGeom>
-          <a:gradFill rotWithShape="1">
-            <a:gsLst>
-              <a:gs pos="0">
-                <a:srgbClr val="CF12D3"/>
-              </a:gs>
-              <a:gs pos="100000">
-                <a:srgbClr val="E82BED"/>
-              </a:gs>
-            </a:gsLst>
-            <a:lin ang="16200000" scaled="0"/>
-          </a:gradFill>
-          <a:ln w="3175">
-            <a:solidFill>
-              <a:srgbClr val="644D64"/>
-            </a:solidFill>
-          </a:ln>
-        </p:spPr>
-        <p:style>
-          <a:lnRef idx="1">
-            <a:schemeClr val="accent1"/>
-          </a:lnRef>
-          <a:fillRef idx="3">
-            <a:schemeClr val="accent1"/>
-          </a:fillRef>
-          <a:effectRef idx="2">
-            <a:schemeClr val="accent1"/>
-          </a:effectRef>
-          <a:fontRef idx="minor">
-            <a:schemeClr val="lt1"/>
-          </a:fontRef>
-        </p:style>
-        <p:txBody>
-          <a:bodyPr rtlCol="0" anchor="t" wrap="square" tIns="91440" bIns="91440"/>
-          <a:lstStyle/>
-          <a:p>
-            <a:pPr algn="l">
-              <a:spcAft>
-                <a:spcPts val="500"/>
-              </a:spcAft>
-            </a:pPr>
-            <a:r>
-              <a:rPr sz="1400" b="1">
-                <a:solidFill>
-                  <a:srgbClr val="FFFFFF"/>
-                </a:solidFill>
-              </a:rPr>
-              <a:t>Phase confusion</a:t>
-            </a:r>
-          </a:p>
-          <a:p>
-            <a:pPr algn="l">
-              <a:spcAft>
-                <a:spcPts val="0"/>
-              </a:spcAft>
-            </a:pPr>
-            <a:r>
-              <a:rPr sz="1400" b="1">
-                <a:solidFill>
-                  <a:srgbClr val="FFFFFF"/>
-                </a:solidFill>
-              </a:rPr>
-              <a:t>Symptom: </a:t>
-            </a:r>
-            <a:r>
-              <a:rPr sz="1400">
-                <a:solidFill>
-                  <a:srgbClr val="FFFFFF"/>
-                </a:solidFill>
-              </a:rPr>
-              <a:t>Create/Update runs during Phase 1-3.</a:t>
-            </a:r>
-          </a:p>
-          <a:p>
-            <a:pPr algn="l">
-              <a:spcAft>
-                <a:spcPts val="0"/>
-              </a:spcAft>
-            </a:pPr>
-            <a:r>
-              <a:rPr sz="1400" b="1">
-                <a:solidFill>
-                  <a:srgbClr val="FFFFFF"/>
-                </a:solidFill>
-              </a:rPr>
-              <a:t>Catch: </a:t>
-            </a:r>
-            <a:r>
-              <a:rPr sz="1400">
-                <a:solidFill>
-                  <a:srgbClr val="FFFFFF"/>
-                </a:solidFill>
-              </a:rPr>
-              <a:t>say "document only, not system" · revert.</a:t>
+              <a:t>Author shows by name, not UUID</a:t>
             </a:r>
           </a:p>
         </p:txBody>
@@ -34637,6 +35156,440 @@
           <a:lstStyle/>
           <a:p>
             <a:r>
+              <a:t>Two failure modes · how to catch them</a:t>
+            </a:r>
+          </a:p>
+        </p:txBody>
+      </p:sp>
+      <p:sp>
+        <p:nvSpPr>
+          <p:cNvPr id="3" name="Text Placeholder 2"/>
+          <p:cNvSpPr>
+            <a:spLocks noGrp="1"/>
+          </p:cNvSpPr>
+          <p:nvPr>
+            <p:ph type="body" idx="15" sz="quarter"/>
+          </p:nvPr>
+        </p:nvSpPr>
+        <p:spPr/>
+        <p:txBody>
+          <a:bodyPr/>
+          <a:lstStyle/>
+          <a:p>
+            <a:r>
+              <a:t>DRIFT · HALLUCINATION</a:t>
+            </a:r>
+          </a:p>
+        </p:txBody>
+      </p:sp>
+      <p:sp>
+        <p:nvSpPr>
+          <p:cNvPr id="4" name="ContentArea"/>
+          <p:cNvSpPr/>
+          <p:nvPr/>
+        </p:nvSpPr>
+        <p:spPr>
+          <a:xfrm>
+            <a:off x="457200" y="1463040"/>
+            <a:ext cx="11064240" cy="4663440"/>
+          </a:xfrm>
+          <a:prstGeom prst="rect">
+            <a:avLst/>
+          </a:prstGeom>
+          <a:noFill/>
+          <a:ln>
+            <a:noFill/>
+          </a:ln>
+        </p:spPr>
+        <p:style>
+          <a:lnRef idx="1">
+            <a:schemeClr val="accent1"/>
+          </a:lnRef>
+          <a:fillRef idx="3">
+            <a:schemeClr val="accent1"/>
+          </a:fillRef>
+          <a:effectRef idx="2">
+            <a:schemeClr val="accent1"/>
+          </a:effectRef>
+          <a:fontRef idx="minor">
+            <a:schemeClr val="lt1"/>
+          </a:fontRef>
+        </p:style>
+        <p:txBody>
+          <a:bodyPr rtlCol="0" anchor="ctr"/>
+          <a:lstStyle/>
+          <a:p>
+            <a:pPr algn="ctr"/>
+          </a:p>
+        </p:txBody>
+      </p:sp>
+      <p:sp>
+        <p:nvSpPr>
+          <p:cNvPr id="5" name="c_1_BlockGrid:0:c_1_Block"/>
+          <p:cNvSpPr/>
+          <p:nvPr/>
+        </p:nvSpPr>
+        <p:spPr>
+          <a:xfrm>
+            <a:off x="457200" y="1463040"/>
+            <a:ext cx="3566160" cy="4663440"/>
+          </a:xfrm>
+          <a:prstGeom prst="rect">
+            <a:avLst/>
+          </a:prstGeom>
+          <a:gradFill rotWithShape="1">
+            <a:gsLst>
+              <a:gs pos="0">
+                <a:srgbClr val="C65F00"/>
+              </a:gs>
+              <a:gs pos="100000">
+                <a:srgbClr val="F97800"/>
+              </a:gs>
+            </a:gsLst>
+            <a:lin ang="16200000" scaled="0"/>
+          </a:gradFill>
+          <a:ln w="3175">
+            <a:solidFill>
+              <a:srgbClr val="5A4D42"/>
+            </a:solidFill>
+          </a:ln>
+        </p:spPr>
+        <p:style>
+          <a:lnRef idx="1">
+            <a:schemeClr val="accent1"/>
+          </a:lnRef>
+          <a:fillRef idx="3">
+            <a:schemeClr val="accent1"/>
+          </a:fillRef>
+          <a:effectRef idx="2">
+            <a:schemeClr val="accent1"/>
+          </a:effectRef>
+          <a:fontRef idx="minor">
+            <a:schemeClr val="lt1"/>
+          </a:fontRef>
+        </p:style>
+        <p:txBody>
+          <a:bodyPr rtlCol="0" anchor="t" wrap="square" tIns="91440" bIns="91440"/>
+          <a:lstStyle/>
+          <a:p>
+            <a:pPr algn="l">
+              <a:spcAft>
+                <a:spcPts val="500"/>
+              </a:spcAft>
+            </a:pPr>
+            <a:r>
+              <a:rPr sz="1400" b="1">
+                <a:solidFill>
+                  <a:srgbClr val="000000"/>
+                </a:solidFill>
+              </a:rPr>
+              <a:t>Spec / plan drift</a:t>
+            </a:r>
+          </a:p>
+          <a:p>
+            <a:pPr algn="l">
+              <a:spcAft>
+                <a:spcPts val="0"/>
+              </a:spcAft>
+            </a:pPr>
+            <a:r>
+              <a:rPr sz="1400" b="1">
+                <a:solidFill>
+                  <a:srgbClr val="000000"/>
+                </a:solidFill>
+              </a:rPr>
+              <a:t>Symptom: </a:t>
+            </a:r>
+            <a:r>
+              <a:rPr sz="1400">
+                <a:solidFill>
+                  <a:srgbClr val="000000"/>
+                </a:solidFill>
+              </a:rPr>
+              <a:t>extra objects, missing ones, silent renames.</a:t>
+            </a:r>
+          </a:p>
+          <a:p>
+            <a:pPr algn="l">
+              <a:spcAft>
+                <a:spcPts val="0"/>
+              </a:spcAft>
+            </a:pPr>
+            <a:r>
+              <a:rPr sz="1400" b="1">
+                <a:solidFill>
+                  <a:srgbClr val="000000"/>
+                </a:solidFill>
+              </a:rPr>
+              <a:t>Catch: </a:t>
+            </a:r>
+            <a:r>
+              <a:rPr sz="1400">
+                <a:solidFill>
+                  <a:srgbClr val="000000"/>
+                </a:solidFill>
+              </a:rPr>
+              <a:t>quote the plan back; force exact list.</a:t>
+            </a:r>
+          </a:p>
+        </p:txBody>
+      </p:sp>
+      <p:sp>
+        <p:nvSpPr>
+          <p:cNvPr id="6" name="c_1_BlockGrid:1:c_2_Block"/>
+          <p:cNvSpPr/>
+          <p:nvPr/>
+        </p:nvSpPr>
+        <p:spPr>
+          <a:xfrm>
+            <a:off x="4206240" y="1463040"/>
+            <a:ext cx="3566160" cy="4663440"/>
+          </a:xfrm>
+          <a:prstGeom prst="rect">
+            <a:avLst/>
+          </a:prstGeom>
+          <a:gradFill rotWithShape="1">
+            <a:gsLst>
+              <a:gs pos="0">
+                <a:srgbClr val="CE0101"/>
+              </a:gs>
+              <a:gs pos="100000">
+                <a:srgbClr val="FC0606"/>
+              </a:gs>
+            </a:gsLst>
+            <a:lin ang="16200000" scaled="0"/>
+          </a:gradFill>
+          <a:ln w="3175">
+            <a:solidFill>
+              <a:srgbClr val="5D4545"/>
+            </a:solidFill>
+          </a:ln>
+        </p:spPr>
+        <p:style>
+          <a:lnRef idx="1">
+            <a:schemeClr val="accent1"/>
+          </a:lnRef>
+          <a:fillRef idx="3">
+            <a:schemeClr val="accent1"/>
+          </a:fillRef>
+          <a:effectRef idx="2">
+            <a:schemeClr val="accent1"/>
+          </a:effectRef>
+          <a:fontRef idx="minor">
+            <a:schemeClr val="lt1"/>
+          </a:fontRef>
+        </p:style>
+        <p:txBody>
+          <a:bodyPr rtlCol="0" anchor="t" wrap="square" tIns="91440" bIns="91440"/>
+          <a:lstStyle/>
+          <a:p>
+            <a:pPr algn="l">
+              <a:spcAft>
+                <a:spcPts val="500"/>
+              </a:spcAft>
+            </a:pPr>
+            <a:r>
+              <a:rPr sz="1400" b="1">
+                <a:solidFill>
+                  <a:srgbClr val="FFFFFF"/>
+                </a:solidFill>
+              </a:rPr>
+              <a:t>Hallucination</a:t>
+            </a:r>
+          </a:p>
+          <a:p>
+            <a:pPr algn="l">
+              <a:spcAft>
+                <a:spcPts val="0"/>
+              </a:spcAft>
+            </a:pPr>
+            <a:r>
+              <a:rPr sz="1400" b="1">
+                <a:solidFill>
+                  <a:srgbClr val="FFFFFF"/>
+                </a:solidFill>
+              </a:rPr>
+              <a:t>Symptom: </a:t>
+            </a:r>
+            <a:r>
+              <a:rPr sz="1400">
+                <a:solidFill>
+                  <a:srgbClr val="FFFFFF"/>
+                </a:solidFill>
+              </a:rPr>
+              <a:t>"All N active" with no Executing trace.</a:t>
+            </a:r>
+          </a:p>
+          <a:p>
+            <a:pPr algn="l">
+              <a:spcAft>
+                <a:spcPts val="0"/>
+              </a:spcAft>
+            </a:pPr>
+            <a:r>
+              <a:rPr sz="1400" b="1">
+                <a:solidFill>
+                  <a:srgbClr val="FFFFFF"/>
+                </a:solidFill>
+              </a:rPr>
+              <a:t>Catch: </a:t>
+            </a:r>
+            <a:r>
+              <a:rPr sz="1400">
+                <a:solidFill>
+                  <a:srgbClr val="FFFFFF"/>
+                </a:solidFill>
+              </a:rPr>
+              <a:t>low token count · ask agent to read each object back.</a:t>
+            </a:r>
+          </a:p>
+        </p:txBody>
+      </p:sp>
+      <p:sp>
+        <p:nvSpPr>
+          <p:cNvPr id="7" name="c_1_BlockGrid:2:c_3_Block"/>
+          <p:cNvSpPr/>
+          <p:nvPr/>
+        </p:nvSpPr>
+        <p:spPr>
+          <a:xfrm>
+            <a:off x="7955280" y="1463040"/>
+            <a:ext cx="3566160" cy="4663440"/>
+          </a:xfrm>
+          <a:prstGeom prst="rect">
+            <a:avLst/>
+          </a:prstGeom>
+          <a:gradFill rotWithShape="1">
+            <a:gsLst>
+              <a:gs pos="0">
+                <a:srgbClr val="CF12D3"/>
+              </a:gs>
+              <a:gs pos="100000">
+                <a:srgbClr val="E82BED"/>
+              </a:gs>
+            </a:gsLst>
+            <a:lin ang="16200000" scaled="0"/>
+          </a:gradFill>
+          <a:ln w="3175">
+            <a:solidFill>
+              <a:srgbClr val="644D64"/>
+            </a:solidFill>
+          </a:ln>
+        </p:spPr>
+        <p:style>
+          <a:lnRef idx="1">
+            <a:schemeClr val="accent1"/>
+          </a:lnRef>
+          <a:fillRef idx="3">
+            <a:schemeClr val="accent1"/>
+          </a:fillRef>
+          <a:effectRef idx="2">
+            <a:schemeClr val="accent1"/>
+          </a:effectRef>
+          <a:fontRef idx="minor">
+            <a:schemeClr val="lt1"/>
+          </a:fontRef>
+        </p:style>
+        <p:txBody>
+          <a:bodyPr rtlCol="0" anchor="t" wrap="square" tIns="91440" bIns="91440"/>
+          <a:lstStyle/>
+          <a:p>
+            <a:pPr algn="l">
+              <a:spcAft>
+                <a:spcPts val="500"/>
+              </a:spcAft>
+            </a:pPr>
+            <a:r>
+              <a:rPr sz="1400" b="1">
+                <a:solidFill>
+                  <a:srgbClr val="FFFFFF"/>
+                </a:solidFill>
+              </a:rPr>
+              <a:t>Phase confusion</a:t>
+            </a:r>
+          </a:p>
+          <a:p>
+            <a:pPr algn="l">
+              <a:spcAft>
+                <a:spcPts val="0"/>
+              </a:spcAft>
+            </a:pPr>
+            <a:r>
+              <a:rPr sz="1400" b="1">
+                <a:solidFill>
+                  <a:srgbClr val="FFFFFF"/>
+                </a:solidFill>
+              </a:rPr>
+              <a:t>Symptom: </a:t>
+            </a:r>
+            <a:r>
+              <a:rPr sz="1400">
+                <a:solidFill>
+                  <a:srgbClr val="FFFFFF"/>
+                </a:solidFill>
+              </a:rPr>
+              <a:t>Create/Update runs during Phase 1-3.</a:t>
+            </a:r>
+          </a:p>
+          <a:p>
+            <a:pPr algn="l">
+              <a:spcAft>
+                <a:spcPts val="0"/>
+              </a:spcAft>
+            </a:pPr>
+            <a:r>
+              <a:rPr sz="1400" b="1">
+                <a:solidFill>
+                  <a:srgbClr val="FFFFFF"/>
+                </a:solidFill>
+              </a:rPr>
+              <a:t>Catch: </a:t>
+            </a:r>
+            <a:r>
+              <a:rPr sz="1400">
+                <a:solidFill>
+                  <a:srgbClr val="FFFFFF"/>
+                </a:solidFill>
+              </a:rPr>
+              <a:t>say "document only, not system" · revert.</a:t>
+            </a:r>
+          </a:p>
+        </p:txBody>
+      </p:sp>
+    </p:spTree>
+  </p:cSld>
+  <p:clrMapOvr>
+    <a:masterClrMapping/>
+  </p:clrMapOvr>
+</p:sld>
+</file>
+
+<file path=ppt/slides/slide12.xml><?xml version="1.0" encoding="utf-8"?>
+<p:sld xmlns:a="http://schemas.openxmlformats.org/drawingml/2006/main" xmlns:p="http://schemas.openxmlformats.org/presentationml/2006/main" xmlns:r="http://schemas.openxmlformats.org/officeDocument/2006/relationships">
+  <p:cSld>
+    <p:spTree>
+      <p:nvGrpSpPr>
+        <p:cNvPr id="1" name=""/>
+        <p:cNvGrpSpPr/>
+        <p:nvPr/>
+      </p:nvGrpSpPr>
+      <p:grpSpPr/>
+      <p:sp>
+        <p:nvSpPr>
+          <p:cNvPr id="2" name="Title 1"/>
+          <p:cNvSpPr>
+            <a:spLocks noGrp="1"/>
+          </p:cNvSpPr>
+          <p:nvPr>
+            <p:ph type="title"/>
+          </p:nvPr>
+        </p:nvSpPr>
+        <p:spPr/>
+        <p:txBody>
+          <a:bodyPr/>
+          <a:lstStyle/>
+          <a:p>
+            <a:r>
               <a:t>What you walk away with</a:t>
             </a:r>
           </a:p>
@@ -35346,7 +36299,7 @@
           <a:lstStyle/>
           <a:p>
             <a:r>
-              <a:t>What the skill teaches</a:t>
+              <a:t>Skill catalog + one example</a:t>
             </a:r>
           </a:p>
         </p:txBody>
@@ -39149,7 +40102,7 @@
           <a:lstStyle/>
           <a:p>
             <a:r>
-              <a:t>The same entity moves through the pipeline</a:t>
+              <a:t>Skill example · activating-objects</a:t>
             </a:r>
           </a:p>
         </p:txBody>
@@ -39170,7 +40123,7 @@
           <a:lstStyle/>
           <a:p>
             <a:r>
-              <a:t>AUTHOR · FROM IDEA TO OBJECT</a:t>
+              <a:t>41 LINES · ONE TASK</a:t>
             </a:r>
           </a:p>
         </p:txBody>
@@ -39218,14 +40171,14 @@
       </p:sp>
       <p:sp>
         <p:nvSpPr>
-          <p:cNvPr id="5" name="c_1_BlockGrid:0:c_1_Block"/>
+          <p:cNvPr id="5" name="c_1_Block"/>
           <p:cNvSpPr/>
           <p:nvPr/>
         </p:nvSpPr>
         <p:spPr>
           <a:xfrm>
             <a:off x="457200" y="1463040"/>
-            <a:ext cx="2697480" cy="4663440"/>
+            <a:ext cx="11064240" cy="914400"/>
           </a:xfrm>
           <a:prstGeom prst="rect">
             <a:avLst/>
@@ -39233,17 +40186,17 @@
           <a:gradFill rotWithShape="1">
             <a:gsLst>
               <a:gs pos="0">
-                <a:srgbClr val="003FE5"/>
+                <a:srgbClr val="7C7C7C"/>
               </a:gs>
               <a:gs pos="100000">
-                <a:srgbClr val="1959FF"/>
+                <a:srgbClr val="959595"/>
               </a:gs>
             </a:gsLst>
             <a:lin ang="16200000" scaled="0"/>
           </a:gradFill>
           <a:ln w="3175">
             <a:solidFill>
-              <a:srgbClr val="4B5366"/>
+              <a:srgbClr val="5F5F5F"/>
             </a:solidFill>
           </a:ln>
         </p:spPr>
@@ -39267,16 +40220,40 @@
           <a:p>
             <a:pPr algn="l">
               <a:spcAft>
-                <a:spcPts val="500"/>
+                <a:spcPts val="0"/>
               </a:spcAft>
             </a:pPr>
             <a:r>
-              <a:rPr sz="1200" b="1">
-                <a:solidFill>
-                  <a:srgbClr val="FFFFFF"/>
+              <a:rPr sz="1400" b="1">
+                <a:solidFill>
+                  <a:srgbClr val="000000"/>
                 </a:solidFill>
               </a:rPr>
-              <a:t>Phase 1 · business</a:t>
+              <a:t>name: </a:t>
+            </a:r>
+            <a:r>
+              <a:rPr sz="1400">
+                <a:solidFill>
+                  <a:srgbClr val="000000"/>
+                </a:solidFill>
+              </a:rPr>
+              <a:t>Activating Objects     </a:t>
+            </a:r>
+            <a:r>
+              <a:rPr sz="1400" b="1">
+                <a:solidFill>
+                  <a:srgbClr val="000000"/>
+                </a:solidFill>
+              </a:rPr>
+              <a:t>tags: </a:t>
+            </a:r>
+            <a:r>
+              <a:rPr sz="1400">
+                <a:solidFill>
+                  <a:srgbClr val="000000"/>
+                </a:solidFill>
+              </a:rPr>
+              <a:t>[sap, activation, governance]</a:t>
             </a:r>
           </a:p>
           <a:p>
@@ -39288,123 +40265,32 @@
             <a:r>
               <a:rPr sz="1400" b="1">
                 <a:solidFill>
-                  <a:srgbClr val="FFFFFF"/>
+                  <a:srgbClr val="000000"/>
                 </a:solidFill>
               </a:rPr>
-              <a:t>Entity: Author</a:t>
-            </a:r>
-          </a:p>
-          <a:p>
-            <a:pPr algn="l" marL="228600" indent="-182880">
-              <a:spcAft>
-                <a:spcPts val="0"/>
-              </a:spcAft>
-              <a:buClr>
-                <a:srgbClr val="FFFFFF"/>
-              </a:buClr>
-              <a:buChar char="•"/>
-            </a:pPr>
-            <a:r>
-              <a:rPr sz="900">
-                <a:solidFill>
-                  <a:srgbClr val="FFFFFF"/>
+              <a:t>description: </a:t>
+            </a:r>
+            <a:r>
+              <a:rPr sz="1400">
+                <a:solidFill>
+                  <a:srgbClr val="000000"/>
                 </a:solidFill>
               </a:rPr>
-              <a:t>Name (string 100, required)</a:t>
-            </a:r>
-          </a:p>
-          <a:p>
-            <a:pPr algn="l" marL="228600" indent="-182880">
-              <a:spcAft>
-                <a:spcPts val="0"/>
-              </a:spcAft>
-              <a:buClr>
-                <a:srgbClr val="FFFFFF"/>
-              </a:buClr>
-              <a:buChar char="•"/>
-            </a:pPr>
-            <a:r>
-              <a:rPr sz="900">
-                <a:solidFill>
-                  <a:srgbClr val="FFFFFF"/>
-                </a:solidFill>
-              </a:rPr>
-              <a:t>Country (string 50)</a:t>
-            </a:r>
-          </a:p>
-          <a:p>
-            <a:pPr algn="l" marL="228600" indent="-182880">
-              <a:spcAft>
-                <a:spcPts val="0"/>
-              </a:spcAft>
-              <a:buClr>
-                <a:srgbClr val="FFFFFF"/>
-              </a:buClr>
-              <a:buChar char="•"/>
-            </a:pPr>
-            <a:r>
-              <a:rPr sz="900">
-                <a:solidFill>
-                  <a:srgbClr val="FFFFFF"/>
-                </a:solidFill>
-              </a:rPr>
-              <a:t>Birth Year (int 4)</a:t>
-            </a:r>
-          </a:p>
-          <a:p>
-            <a:pPr algn="l" marL="228600" indent="-182880">
-              <a:spcAft>
-                <a:spcPts val="0"/>
-              </a:spcAft>
-              <a:buClr>
-                <a:srgbClr val="FFFFFF"/>
-              </a:buClr>
-              <a:buChar char="•"/>
-            </a:pPr>
-            <a:r>
-              <a:rPr sz="900">
-                <a:solidFill>
-                  <a:srgbClr val="FFFFFF"/>
-                </a:solidFill>
-              </a:rPr>
-              <a:t>Biography (text)</a:t>
-            </a:r>
-          </a:p>
-          <a:p>
-            <a:pPr algn="l">
-              <a:spcAft>
-                <a:spcPts val="0"/>
-              </a:spcAft>
-            </a:pPr>
-            <a:r>
-              <a:rPr sz="1400" b="1">
-                <a:solidFill>
-                  <a:srgbClr val="FFFFFF"/>
-                </a:solidFill>
-              </a:rPr>
-              <a:t>Rule: </a:t>
-            </a:r>
-            <a:r>
-              <a:rPr sz="1400">
-                <a:solidFill>
-                  <a:srgbClr val="FFFFFF"/>
-                </a:solidFill>
-              </a:rPr>
-              <a:t>name unique; birth-year 1000..now.</a:t>
-            </a:r>
-          </a:p>
-        </p:txBody>
-      </p:sp>
-      <p:sp>
-        <p:nvSpPr>
-          <p:cNvPr id="6" name="c_1_BlockGrid:1:c_2_Block"/>
+              <a:t>Rules for activating ABAP objects safely — never bare 'activate all', group activation for circular references, special tool for BDEF</a:t>
+            </a:r>
+          </a:p>
+        </p:txBody>
+      </p:sp>
+      <p:sp>
+        <p:nvSpPr>
+          <p:cNvPr id="6" name="c_1_BlockGrid:0:c_2_Block"/>
           <p:cNvSpPr/>
           <p:nvPr/>
         </p:nvSpPr>
         <p:spPr>
           <a:xfrm>
-            <a:off x="3246120" y="1463040"/>
-            <a:ext cx="2697480" cy="4663440"/>
+            <a:off x="457200" y="2514600"/>
+            <a:ext cx="5440680" cy="3611880"/>
           </a:xfrm>
           <a:prstGeom prst="rect">
             <a:avLst/>
@@ -39412,17 +40298,17 @@
           <a:gradFill rotWithShape="1">
             <a:gsLst>
               <a:gs pos="0">
-                <a:srgbClr val="0D6976"/>
+                <a:srgbClr val="CE0101"/>
               </a:gs>
               <a:gs pos="100000">
-                <a:srgbClr val="1292A3"/>
+                <a:srgbClr val="FC0606"/>
               </a:gs>
             </a:gsLst>
             <a:lin ang="16200000" scaled="0"/>
           </a:gradFill>
           <a:ln w="3175">
             <a:solidFill>
-              <a:srgbClr val="303B3D"/>
+              <a:srgbClr val="5D4545"/>
             </a:solidFill>
           </a:ln>
         </p:spPr>
@@ -39455,22 +40341,7 @@
                   <a:srgbClr val="FFFFFF"/>
                 </a:solidFill>
               </a:rPr>
-              <a:t>Phase 2 · spec</a:t>
-            </a:r>
-          </a:p>
-          <a:p>
-            <a:pPr algn="l">
-              <a:spcAft>
-                <a:spcPts val="0"/>
-              </a:spcAft>
-            </a:pPr>
-            <a:r>
-              <a:rPr sz="1400" b="1">
-                <a:solidFill>
-                  <a:srgbClr val="FFFFFF"/>
-                </a:solidFill>
-              </a:rPr>
-              <a:t>Table Z##_AUTHOR</a:t>
+              <a:t>Hard rules</a:t>
             </a:r>
           </a:p>
           <a:p>
@@ -39489,7 +40360,7 @@
                   <a:srgbClr val="FFFFFF"/>
                 </a:solidFill>
               </a:rPr>
-              <a:t>author_id uuid · key</a:t>
+              <a:t>Never bare 'activate all inactive' on a shared system — always filter by prefix Z##_.</a:t>
             </a:r>
           </a:p>
           <a:p>
@@ -39508,7 +40379,7 @@
                   <a:srgbClr val="FFFFFF"/>
                 </a:solidFill>
               </a:rPr>
-              <a:t>name z##_e_name (z##_d_name CHAR 100)</a:t>
+              <a:t>Syntax-check each object before activating; activation is expensive and partial failures cascade.</a:t>
             </a:r>
           </a:p>
           <a:p>
@@ -39527,7 +40398,7 @@
                   <a:srgbClr val="FFFFFF"/>
                 </a:solidFill>
               </a:rPr>
-              <a:t>country z##_e_country</a:t>
+              <a:t>Group activation for circular refs — CDS R views, CDS C views, BDEF + BIMP.</a:t>
             </a:r>
           </a:p>
           <a:p>
@@ -39546,215 +40417,21 @@
                   <a:srgbClr val="FFFFFF"/>
                 </a:solidFill>
               </a:rPr>
-              <a:t>birth_year z##_e_year (NUMC 4)</a:t>
-            </a:r>
-          </a:p>
-          <a:p>
-            <a:pPr algn="l" marL="228600" indent="-182880">
-              <a:spcAft>
-                <a:spcPts val="0"/>
-              </a:spcAft>
-              <a:buClr>
-                <a:srgbClr val="FFFFFF"/>
-              </a:buClr>
-              <a:buChar char="•"/>
-            </a:pPr>
-            <a:r>
-              <a:rPr sz="900">
-                <a:solidFill>
-                  <a:srgbClr val="FFFFFF"/>
-                </a:solidFill>
-              </a:rPr>
-              <a:t>biography STRING</a:t>
-            </a:r>
-          </a:p>
-        </p:txBody>
-      </p:sp>
-      <p:sp>
-        <p:nvSpPr>
-          <p:cNvPr id="7" name="c_1_BlockGrid:2:c_3_Block"/>
+              <a:t>BDEF: use ActivateBehaviorDefinition, not the generic ActivateObjects.</a:t>
+            </a:r>
+          </a:p>
+        </p:txBody>
+      </p:sp>
+      <p:sp>
+        <p:nvSpPr>
+          <p:cNvPr id="7" name="c_1_BlockGrid:1:c_3_Block"/>
           <p:cNvSpPr/>
           <p:nvPr/>
         </p:nvSpPr>
         <p:spPr>
           <a:xfrm>
-            <a:off x="6035040" y="1463040"/>
-            <a:ext cx="2697480" cy="4663440"/>
-          </a:xfrm>
-          <a:prstGeom prst="rect">
-            <a:avLst/>
-          </a:prstGeom>
-          <a:gradFill rotWithShape="1">
-            <a:gsLst>
-              <a:gs pos="0">
-                <a:srgbClr val="CF12D3"/>
-              </a:gs>
-              <a:gs pos="100000">
-                <a:srgbClr val="E82BED"/>
-              </a:gs>
-            </a:gsLst>
-            <a:lin ang="16200000" scaled="0"/>
-          </a:gradFill>
-          <a:ln w="3175">
-            <a:solidFill>
-              <a:srgbClr val="644D64"/>
-            </a:solidFill>
-          </a:ln>
-        </p:spPr>
-        <p:style>
-          <a:lnRef idx="1">
-            <a:schemeClr val="accent1"/>
-          </a:lnRef>
-          <a:fillRef idx="3">
-            <a:schemeClr val="accent1"/>
-          </a:fillRef>
-          <a:effectRef idx="2">
-            <a:schemeClr val="accent1"/>
-          </a:effectRef>
-          <a:fontRef idx="minor">
-            <a:schemeClr val="lt1"/>
-          </a:fontRef>
-        </p:style>
-        <p:txBody>
-          <a:bodyPr rtlCol="0" anchor="t" wrap="square" tIns="91440" bIns="91440"/>
-          <a:lstStyle/>
-          <a:p>
-            <a:pPr algn="l">
-              <a:spcAft>
-                <a:spcPts val="500"/>
-              </a:spcAft>
-            </a:pPr>
-            <a:r>
-              <a:rPr sz="1200" b="1">
-                <a:solidFill>
-                  <a:srgbClr val="FFFFFF"/>
-                </a:solidFill>
-              </a:rPr>
-              <a:t>Phase 3 · plan</a:t>
-            </a:r>
-          </a:p>
-          <a:p>
-            <a:pPr algn="l">
-              <a:spcAft>
-                <a:spcPts val="0"/>
-              </a:spcAft>
-            </a:pPr>
-            <a:r>
-              <a:rPr sz="1400" b="1">
-                <a:solidFill>
-                  <a:srgbClr val="FFFFFF"/>
-                </a:solidFill>
-              </a:rPr>
-              <a:t>Step group · Author</a:t>
-            </a:r>
-          </a:p>
-          <a:p>
-            <a:pPr algn="l" marL="228600" indent="-182880">
-              <a:spcAft>
-                <a:spcPts val="0"/>
-              </a:spcAft>
-              <a:buClr>
-                <a:srgbClr val="FFFFFF"/>
-              </a:buClr>
-              <a:buChar char="•"/>
-            </a:pPr>
-            <a:r>
-              <a:rPr sz="900">
-                <a:solidFill>
-                  <a:srgbClr val="FFFFFF"/>
-                </a:solidFill>
-              </a:rPr>
-              <a:t>1.1 create 5 domains</a:t>
-            </a:r>
-          </a:p>
-          <a:p>
-            <a:pPr algn="l" marL="228600" indent="-182880">
-              <a:spcAft>
-                <a:spcPts val="0"/>
-              </a:spcAft>
-              <a:buClr>
-                <a:srgbClr val="FFFFFF"/>
-              </a:buClr>
-              <a:buChar char="•"/>
-            </a:pPr>
-            <a:r>
-              <a:rPr sz="900">
-                <a:solidFill>
-                  <a:srgbClr val="FFFFFF"/>
-                </a:solidFill>
-              </a:rPr>
-              <a:t>1.2 create 5 data elements</a:t>
-            </a:r>
-          </a:p>
-          <a:p>
-            <a:pPr algn="l" marL="228600" indent="-182880">
-              <a:spcAft>
-                <a:spcPts val="0"/>
-              </a:spcAft>
-              <a:buClr>
-                <a:srgbClr val="FFFFFF"/>
-              </a:buClr>
-              <a:buChar char="•"/>
-            </a:pPr>
-            <a:r>
-              <a:rPr sz="900">
-                <a:solidFill>
-                  <a:srgbClr val="FFFFFF"/>
-                </a:solidFill>
-              </a:rPr>
-              <a:t>2.1 create Z##_AUTHOR + draft</a:t>
-            </a:r>
-          </a:p>
-          <a:p>
-            <a:pPr algn="l" marL="228600" indent="-182880">
-              <a:spcAft>
-                <a:spcPts val="0"/>
-              </a:spcAft>
-              <a:buClr>
-                <a:srgbClr val="FFFFFF"/>
-              </a:buClr>
-              <a:buChar char="•"/>
-            </a:pPr>
-            <a:r>
-              <a:rPr sz="900">
-                <a:solidFill>
-                  <a:srgbClr val="FFFFFF"/>
-                </a:solidFill>
-              </a:rPr>
-              <a:t>3.1 CDS Z##_R_AUTHOR + C view</a:t>
-            </a:r>
-          </a:p>
-          <a:p>
-            <a:pPr algn="l" marL="228600" indent="-182880">
-              <a:spcAft>
-                <a:spcPts val="0"/>
-              </a:spcAft>
-              <a:buClr>
-                <a:srgbClr val="FFFFFF"/>
-              </a:buClr>
-              <a:buChar char="•"/>
-            </a:pPr>
-            <a:r>
-              <a:rPr sz="900">
-                <a:solidFill>
-                  <a:srgbClr val="FFFFFF"/>
-                </a:solidFill>
-              </a:rPr>
-              <a:t>4.1 BDEF + BIMP + activate</a:t>
-            </a:r>
-          </a:p>
-        </p:txBody>
-      </p:sp>
-      <p:sp>
-        <p:nvSpPr>
-          <p:cNvPr id="8" name="c_1_BlockGrid:3:c_4_Block"/>
-          <p:cNvSpPr/>
-          <p:nvPr/>
-        </p:nvSpPr>
-        <p:spPr>
-          <a:xfrm>
-            <a:off x="8823960" y="1463040"/>
-            <a:ext cx="2697480" cy="4663440"/>
+            <a:off x="6080760" y="2514600"/>
+            <a:ext cx="5440680" cy="3611880"/>
           </a:xfrm>
           <a:prstGeom prst="rect">
             <a:avLst/>
@@ -39805,22 +40482,7 @@
                   <a:srgbClr val="000000"/>
                 </a:solidFill>
               </a:rPr>
-              <a:t>Phase 4 · objects</a:t>
-            </a:r>
-          </a:p>
-          <a:p>
-            <a:pPr algn="l">
-              <a:spcAft>
-                <a:spcPts val="0"/>
-              </a:spcAft>
-            </a:pPr>
-            <a:r>
-              <a:rPr sz="1400" b="1">
-                <a:solidFill>
-                  <a:srgbClr val="000000"/>
-                </a:solidFill>
-              </a:rPr>
-              <a:t>Active on SAP</a:t>
+              <a:t>After + common errors</a:t>
             </a:r>
           </a:p>
           <a:p>
@@ -39839,83 +40501,76 @@
                   <a:srgbClr val="000000"/>
                 </a:solidFill>
               </a:rPr>
-              <a:t>DOMA · DTEL · 5+5</a:t>
-            </a:r>
-          </a:p>
-          <a:p>
-            <a:pPr algn="l" marL="228600" indent="-182880">
+              <a:t>After: re-syntax-check; Read… each object and confirm active: true.</a:t>
+            </a:r>
+          </a:p>
+          <a:p>
+            <a:pPr algn="l">
               <a:spcAft>
                 <a:spcPts val="0"/>
               </a:spcAft>
-              <a:buClr>
-                <a:srgbClr val="000000"/>
-              </a:buClr>
-              <a:buChar char="•"/>
             </a:pPr>
             <a:r>
-              <a:rPr sz="900">
+              <a:rPr sz="1400" b="1">
                 <a:solidFill>
                   <a:srgbClr val="000000"/>
                 </a:solidFill>
               </a:rPr>
-              <a:t>TABL Z##_AUTHOR + _D draft</a:t>
-            </a:r>
-          </a:p>
-          <a:p>
-            <a:pPr algn="l" marL="228600" indent="-182880">
+              <a:t>Activated unrelated objects → </a:t>
+            </a:r>
+            <a:r>
+              <a:rPr sz="1400">
+                <a:solidFill>
+                  <a:srgbClr val="000000"/>
+                </a:solidFill>
+              </a:rPr>
+              <a:t>missing prefix filter.</a:t>
+            </a:r>
+          </a:p>
+          <a:p>
+            <a:pPr algn="l">
               <a:spcAft>
                 <a:spcPts val="0"/>
               </a:spcAft>
-              <a:buClr>
-                <a:srgbClr val="000000"/>
-              </a:buClr>
-              <a:buChar char="•"/>
             </a:pPr>
             <a:r>
-              <a:rPr sz="900">
+              <a:rPr sz="1400" b="1">
                 <a:solidFill>
                   <a:srgbClr val="000000"/>
                 </a:solidFill>
               </a:rPr>
-              <a:t>DDLS Z##_R_AUTHOR + C</a:t>
-            </a:r>
-          </a:p>
-          <a:p>
-            <a:pPr algn="l" marL="228600" indent="-182880">
+              <a:t>Still inactive after activate → </a:t>
+            </a:r>
+            <a:r>
+              <a:rPr sz="1400">
+                <a:solidFill>
+                  <a:srgbClr val="000000"/>
+                </a:solidFill>
+              </a:rPr>
+              <a:t>wrong tool (BDEF via ActivateObjects).</a:t>
+            </a:r>
+          </a:p>
+          <a:p>
+            <a:pPr algn="l">
               <a:spcAft>
                 <a:spcPts val="0"/>
               </a:spcAft>
-              <a:buClr>
-                <a:srgbClr val="000000"/>
-              </a:buClr>
-              <a:buChar char="•"/>
             </a:pPr>
             <a:r>
-              <a:rPr sz="900">
+              <a:rPr sz="1400" b="1">
                 <a:solidFill>
                   <a:srgbClr val="000000"/>
                 </a:solidFill>
               </a:rPr>
-              <a:t>BDEF + BIMP class</a:t>
-            </a:r>
-          </a:p>
-          <a:p>
-            <a:pPr algn="l" marL="228600" indent="-182880">
-              <a:spcAft>
-                <a:spcPts val="0"/>
-              </a:spcAft>
-              <a:buClr>
-                <a:srgbClr val="000000"/>
-              </a:buClr>
-              <a:buChar char="•"/>
-            </a:pPr>
-            <a:r>
-              <a:rPr sz="900">
+              <a:t>Half-active layer → </a:t>
+            </a:r>
+            <a:r>
+              <a:rPr sz="1400">
                 <a:solidFill>
                   <a:srgbClr val="000000"/>
                 </a:solidFill>
               </a:rPr>
-              <a:t>Service + binding</a:t>
+              <a:t>activated one-by-one; group-activate instead.</a:t>
             </a:r>
           </a:p>
         </p:txBody>
@@ -39954,7 +40609,7 @@
           <a:lstStyle/>
           <a:p>
             <a:r>
-              <a:t>What got built · 72 objects, all active</a:t>
+              <a:t>The same entity moves through the pipeline</a:t>
             </a:r>
           </a:p>
         </p:txBody>
@@ -39975,7 +40630,7 @@
           <a:lstStyle/>
           <a:p>
             <a:r>
-              <a:t>4 ENTITIES · 1 RAP APP</a:t>
+              <a:t>AUTHOR · FROM IDEA TO OBJECT</a:t>
             </a:r>
           </a:p>
         </p:txBody>
@@ -40023,442 +40678,14 @@
       </p:sp>
       <p:sp>
         <p:nvSpPr>
-          <p:cNvPr id="5" name="c_1_BlockGrid:0:c_1_Block:container"/>
+          <p:cNvPr id="5" name="c_1_BlockGrid:0:c_1_Block"/>
           <p:cNvSpPr/>
           <p:nvPr/>
         </p:nvSpPr>
         <p:spPr>
           <a:xfrm>
             <a:off x="457200" y="1463040"/>
-            <a:ext cx="2697480" cy="1554480"/>
-          </a:xfrm>
-          <a:prstGeom prst="rect">
-            <a:avLst/>
-          </a:prstGeom>
-          <a:noFill/>
-          <a:ln>
-            <a:noFill/>
-          </a:ln>
-        </p:spPr>
-        <p:style>
-          <a:lnRef idx="1">
-            <a:schemeClr val="accent1"/>
-          </a:lnRef>
-          <a:fillRef idx="3">
-            <a:schemeClr val="accent1"/>
-          </a:fillRef>
-          <a:effectRef idx="2">
-            <a:schemeClr val="accent1"/>
-          </a:effectRef>
-          <a:fontRef idx="minor">
-            <a:schemeClr val="lt1"/>
-          </a:fontRef>
-        </p:style>
-        <p:txBody>
-          <a:bodyPr rtlCol="0" anchor="ctr"/>
-          <a:lstStyle/>
-          <a:p>
-            <a:pPr algn="ctr"/>
-          </a:p>
-        </p:txBody>
-      </p:sp>
-      <p:sp>
-        <p:nvSpPr>
-          <p:cNvPr id="6" name="c_1_BlockGrid:0:c_1_Block:metric"/>
-          <p:cNvSpPr txBox="1"/>
-          <p:nvPr/>
-        </p:nvSpPr>
-        <p:spPr>
-          <a:xfrm>
-            <a:off x="640080" y="1600200"/>
-            <a:ext cx="2331720" cy="408939"/>
-          </a:xfrm>
-          <a:prstGeom prst="rect">
-            <a:avLst/>
-          </a:prstGeom>
-          <a:noFill/>
-        </p:spPr>
-        <p:txBody>
-          <a:bodyPr wrap="none" lIns="0" rIns="0" tIns="0" bIns="0">
-            <a:spAutoFit/>
-          </a:bodyPr>
-          <a:lstStyle/>
-          <a:p>
-            <a:pPr algn="ctr"/>
-            <a:r>
-              <a:rPr sz="2800" b="1">
-                <a:solidFill>
-                  <a:srgbClr val="107E8D"/>
-                </a:solidFill>
-              </a:rPr>
-              <a:t>72</a:t>
-            </a:r>
-          </a:p>
-        </p:txBody>
-      </p:sp>
-      <p:sp>
-        <p:nvSpPr>
-          <p:cNvPr id="7" name="c_1_BlockGrid:0:c_1_Block:content"/>
-          <p:cNvSpPr txBox="1"/>
-          <p:nvPr/>
-        </p:nvSpPr>
-        <p:spPr>
-          <a:xfrm>
-            <a:off x="640080" y="2077719"/>
-            <a:ext cx="2331720" cy="219074"/>
-          </a:xfrm>
-          <a:prstGeom prst="rect">
-            <a:avLst/>
-          </a:prstGeom>
-          <a:noFill/>
-        </p:spPr>
-        <p:txBody>
-          <a:bodyPr wrap="square" lIns="0" rIns="0" tIns="0" bIns="0" anchor="t"/>
-          <a:lstStyle/>
-          <a:p>
-            <a:pPr algn="ctr"/>
-            <a:r>
-              <a:rPr sz="1400">
-                <a:solidFill>
-                  <a:srgbClr val="000000"/>
-                </a:solidFill>
-              </a:rPr>
-              <a:t>objects active</a:t>
-            </a:r>
-          </a:p>
-        </p:txBody>
-      </p:sp>
-      <p:sp>
-        <p:nvSpPr>
-          <p:cNvPr id="8" name="c_1_BlockGrid:1:c_2_Block:container"/>
-          <p:cNvSpPr/>
-          <p:nvPr/>
-        </p:nvSpPr>
-        <p:spPr>
-          <a:xfrm>
-            <a:off x="3246120" y="1463040"/>
-            <a:ext cx="2697480" cy="1554480"/>
-          </a:xfrm>
-          <a:prstGeom prst="rect">
-            <a:avLst/>
-          </a:prstGeom>
-          <a:noFill/>
-          <a:ln>
-            <a:noFill/>
-          </a:ln>
-        </p:spPr>
-        <p:style>
-          <a:lnRef idx="1">
-            <a:schemeClr val="accent1"/>
-          </a:lnRef>
-          <a:fillRef idx="3">
-            <a:schemeClr val="accent1"/>
-          </a:fillRef>
-          <a:effectRef idx="2">
-            <a:schemeClr val="accent1"/>
-          </a:effectRef>
-          <a:fontRef idx="minor">
-            <a:schemeClr val="lt1"/>
-          </a:fontRef>
-        </p:style>
-        <p:txBody>
-          <a:bodyPr rtlCol="0" anchor="ctr"/>
-          <a:lstStyle/>
-          <a:p>
-            <a:pPr algn="ctr"/>
-          </a:p>
-        </p:txBody>
-      </p:sp>
-      <p:sp>
-        <p:nvSpPr>
-          <p:cNvPr id="9" name="c_1_BlockGrid:1:c_2_Block:metric"/>
-          <p:cNvSpPr txBox="1"/>
-          <p:nvPr/>
-        </p:nvSpPr>
-        <p:spPr>
-          <a:xfrm>
-            <a:off x="3429000" y="1600200"/>
-            <a:ext cx="2331720" cy="408939"/>
-          </a:xfrm>
-          <a:prstGeom prst="rect">
-            <a:avLst/>
-          </a:prstGeom>
-          <a:noFill/>
-        </p:spPr>
-        <p:txBody>
-          <a:bodyPr wrap="none" lIns="0" rIns="0" tIns="0" bIns="0">
-            <a:spAutoFit/>
-          </a:bodyPr>
-          <a:lstStyle/>
-          <a:p>
-            <a:pPr algn="ctr"/>
-            <a:r>
-              <a:rPr sz="2800" b="1">
-                <a:solidFill>
-                  <a:srgbClr val="0047FF"/>
-                </a:solidFill>
-              </a:rPr>
-              <a:t>77</a:t>
-            </a:r>
-          </a:p>
-        </p:txBody>
-      </p:sp>
-      <p:sp>
-        <p:nvSpPr>
-          <p:cNvPr id="10" name="c_1_BlockGrid:1:c_2_Block:content"/>
-          <p:cNvSpPr txBox="1"/>
-          <p:nvPr/>
-        </p:nvSpPr>
-        <p:spPr>
-          <a:xfrm>
-            <a:off x="3429000" y="2077719"/>
-            <a:ext cx="2331720" cy="219074"/>
-          </a:xfrm>
-          <a:prstGeom prst="rect">
-            <a:avLst/>
-          </a:prstGeom>
-          <a:noFill/>
-        </p:spPr>
-        <p:txBody>
-          <a:bodyPr wrap="square" lIns="0" rIns="0" tIns="0" bIns="0" anchor="t"/>
-          <a:lstStyle/>
-          <a:p>
-            <a:pPr algn="ctr"/>
-            <a:r>
-              <a:rPr sz="1400">
-                <a:solidFill>
-                  <a:srgbClr val="000000"/>
-                </a:solidFill>
-              </a:rPr>
-              <a:t>API prompts in P4</a:t>
-            </a:r>
-          </a:p>
-        </p:txBody>
-      </p:sp>
-      <p:sp>
-        <p:nvSpPr>
-          <p:cNvPr id="11" name="c_1_BlockGrid:2:c_3_Block:container"/>
-          <p:cNvSpPr/>
-          <p:nvPr/>
-        </p:nvSpPr>
-        <p:spPr>
-          <a:xfrm>
-            <a:off x="6035040" y="1463040"/>
-            <a:ext cx="2697480" cy="1554480"/>
-          </a:xfrm>
-          <a:prstGeom prst="rect">
-            <a:avLst/>
-          </a:prstGeom>
-          <a:noFill/>
-          <a:ln>
-            <a:noFill/>
-          </a:ln>
-        </p:spPr>
-        <p:style>
-          <a:lnRef idx="1">
-            <a:schemeClr val="accent1"/>
-          </a:lnRef>
-          <a:fillRef idx="3">
-            <a:schemeClr val="accent1"/>
-          </a:fillRef>
-          <a:effectRef idx="2">
-            <a:schemeClr val="accent1"/>
-          </a:effectRef>
-          <a:fontRef idx="minor">
-            <a:schemeClr val="lt1"/>
-          </a:fontRef>
-        </p:style>
-        <p:txBody>
-          <a:bodyPr rtlCol="0" anchor="ctr"/>
-          <a:lstStyle/>
-          <a:p>
-            <a:pPr algn="ctr"/>
-          </a:p>
-        </p:txBody>
-      </p:sp>
-      <p:sp>
-        <p:nvSpPr>
-          <p:cNvPr id="12" name="c_1_BlockGrid:2:c_3_Block:metric"/>
-          <p:cNvSpPr txBox="1"/>
-          <p:nvPr/>
-        </p:nvSpPr>
-        <p:spPr>
-          <a:xfrm>
-            <a:off x="6217920" y="1600200"/>
-            <a:ext cx="2331720" cy="408939"/>
-          </a:xfrm>
-          <a:prstGeom prst="rect">
-            <a:avLst/>
-          </a:prstGeom>
-          <a:noFill/>
-        </p:spPr>
-        <p:txBody>
-          <a:bodyPr wrap="none" lIns="0" rIns="0" tIns="0" bIns="0">
-            <a:spAutoFit/>
-          </a:bodyPr>
-          <a:lstStyle/>
-          <a:p>
-            <a:pPr algn="ctr"/>
-            <a:r>
-              <a:rPr sz="2800" b="1">
-                <a:solidFill>
-                  <a:srgbClr val="E06C00"/>
-                </a:solidFill>
-              </a:rPr>
-              <a:t>~$19</a:t>
-            </a:r>
-          </a:p>
-        </p:txBody>
-      </p:sp>
-      <p:sp>
-        <p:nvSpPr>
-          <p:cNvPr id="13" name="c_1_BlockGrid:2:c_3_Block:content"/>
-          <p:cNvSpPr txBox="1"/>
-          <p:nvPr/>
-        </p:nvSpPr>
-        <p:spPr>
-          <a:xfrm>
-            <a:off x="6217920" y="2077719"/>
-            <a:ext cx="2331720" cy="219074"/>
-          </a:xfrm>
-          <a:prstGeom prst="rect">
-            <a:avLst/>
-          </a:prstGeom>
-          <a:noFill/>
-        </p:spPr>
-        <p:txBody>
-          <a:bodyPr wrap="square" lIns="0" rIns="0" tIns="0" bIns="0" anchor="t"/>
-          <a:lstStyle/>
-          <a:p>
-            <a:pPr algn="ctr"/>
-            <a:r>
-              <a:rPr sz="1400">
-                <a:solidFill>
-                  <a:srgbClr val="000000"/>
-                </a:solidFill>
-              </a:rPr>
-              <a:t>API cost · vs ~$2k manual</a:t>
-            </a:r>
-          </a:p>
-        </p:txBody>
-      </p:sp>
-      <p:sp>
-        <p:nvSpPr>
-          <p:cNvPr id="14" name="c_1_BlockGrid:3:c_4_Block:container"/>
-          <p:cNvSpPr/>
-          <p:nvPr/>
-        </p:nvSpPr>
-        <p:spPr>
-          <a:xfrm>
-            <a:off x="8823960" y="1463040"/>
-            <a:ext cx="2697480" cy="1554480"/>
-          </a:xfrm>
-          <a:prstGeom prst="rect">
-            <a:avLst/>
-          </a:prstGeom>
-          <a:noFill/>
-          <a:ln>
-            <a:noFill/>
-          </a:ln>
-        </p:spPr>
-        <p:style>
-          <a:lnRef idx="1">
-            <a:schemeClr val="accent1"/>
-          </a:lnRef>
-          <a:fillRef idx="3">
-            <a:schemeClr val="accent1"/>
-          </a:fillRef>
-          <a:effectRef idx="2">
-            <a:schemeClr val="accent1"/>
-          </a:effectRef>
-          <a:fontRef idx="minor">
-            <a:schemeClr val="lt1"/>
-          </a:fontRef>
-        </p:style>
-        <p:txBody>
-          <a:bodyPr rtlCol="0" anchor="ctr"/>
-          <a:lstStyle/>
-          <a:p>
-            <a:pPr algn="ctr"/>
-          </a:p>
-        </p:txBody>
-      </p:sp>
-      <p:sp>
-        <p:nvSpPr>
-          <p:cNvPr id="15" name="c_1_BlockGrid:3:c_4_Block:metric"/>
-          <p:cNvSpPr txBox="1"/>
-          <p:nvPr/>
-        </p:nvSpPr>
-        <p:spPr>
-          <a:xfrm>
-            <a:off x="9006840" y="1600200"/>
-            <a:ext cx="2331720" cy="408939"/>
-          </a:xfrm>
-          <a:prstGeom prst="rect">
-            <a:avLst/>
-          </a:prstGeom>
-          <a:noFill/>
-        </p:spPr>
-        <p:txBody>
-          <a:bodyPr wrap="none" lIns="0" rIns="0" tIns="0" bIns="0">
-            <a:spAutoFit/>
-          </a:bodyPr>
-          <a:lstStyle/>
-          <a:p>
-            <a:pPr algn="ctr"/>
-            <a:r>
-              <a:rPr sz="2800" b="1">
-                <a:solidFill>
-                  <a:srgbClr val="E614EB"/>
-                </a:solidFill>
-              </a:rPr>
-              <a:t>~3h</a:t>
-            </a:r>
-          </a:p>
-        </p:txBody>
-      </p:sp>
-      <p:sp>
-        <p:nvSpPr>
-          <p:cNvPr id="16" name="c_1_BlockGrid:3:c_4_Block:content"/>
-          <p:cNvSpPr txBox="1"/>
-          <p:nvPr/>
-        </p:nvSpPr>
-        <p:spPr>
-          <a:xfrm>
-            <a:off x="9006840" y="2077719"/>
-            <a:ext cx="2331720" cy="219074"/>
-          </a:xfrm>
-          <a:prstGeom prst="rect">
-            <a:avLst/>
-          </a:prstGeom>
-          <a:noFill/>
-        </p:spPr>
-        <p:txBody>
-          <a:bodyPr wrap="square" lIns="0" rIns="0" tIns="0" bIns="0" anchor="t"/>
-          <a:lstStyle/>
-          <a:p>
-            <a:pPr algn="ctr"/>
-            <a:r>
-              <a:rPr sz="1400">
-                <a:solidFill>
-                  <a:srgbClr val="000000"/>
-                </a:solidFill>
-              </a:rPr>
-              <a:t>wall-clock · vs ~2 weeks</a:t>
-            </a:r>
-          </a:p>
-        </p:txBody>
-      </p:sp>
-      <p:sp>
-        <p:nvSpPr>
-          <p:cNvPr id="17" name="c_2_BlockGrid:0:c_5_Block"/>
-          <p:cNvSpPr/>
-          <p:nvPr/>
-        </p:nvSpPr>
-        <p:spPr>
-          <a:xfrm>
-            <a:off x="457200" y="3200400"/>
-            <a:ext cx="3566160" cy="2926080"/>
+            <a:ext cx="2697480" cy="4663440"/>
           </a:xfrm>
           <a:prstGeom prst="rect">
             <a:avLst/>
@@ -40504,12 +40731,27 @@
               </a:spcAft>
             </a:pPr>
             <a:r>
+              <a:rPr sz="1200" b="1">
+                <a:solidFill>
+                  <a:srgbClr val="FFFFFF"/>
+                </a:solidFill>
+              </a:rPr>
+              <a:t>Phase 1 · business</a:t>
+            </a:r>
+          </a:p>
+          <a:p>
+            <a:pPr algn="l">
+              <a:spcAft>
+                <a:spcPts val="0"/>
+              </a:spcAft>
+            </a:pPr>
+            <a:r>
               <a:rPr sz="1400" b="1">
                 <a:solidFill>
                   <a:srgbClr val="FFFFFF"/>
                 </a:solidFill>
               </a:rPr>
-              <a:t>DDIC layer</a:t>
+              <a:t>Entity: Author</a:t>
             </a:r>
           </a:p>
           <a:p>
@@ -40523,12 +40765,12 @@
               <a:buChar char="•"/>
             </a:pPr>
             <a:r>
-              <a:rPr sz="1100">
+              <a:rPr sz="900">
                 <a:solidFill>
                   <a:srgbClr val="FFFFFF"/>
                 </a:solidFill>
               </a:rPr>
-              <a:t>20 domains (DOMA)</a:t>
+              <a:t>Name (string 100, required)</a:t>
             </a:r>
           </a:p>
           <a:p>
@@ -40542,12 +40784,12 @@
               <a:buChar char="•"/>
             </a:pPr>
             <a:r>
-              <a:rPr sz="1100">
+              <a:rPr sz="900">
                 <a:solidFill>
                   <a:srgbClr val="FFFFFF"/>
                 </a:solidFill>
               </a:rPr>
-              <a:t>20 data elements (DTEL)</a:t>
+              <a:t>Country (string 50)</a:t>
             </a:r>
           </a:p>
           <a:p>
@@ -40561,12 +40803,12 @@
               <a:buChar char="•"/>
             </a:pPr>
             <a:r>
-              <a:rPr sz="1100">
+              <a:rPr sz="900">
                 <a:solidFill>
                   <a:srgbClr val="FFFFFF"/>
                 </a:solidFill>
               </a:rPr>
-              <a:t>4 persistent tables (TABL)</a:t>
+              <a:t>Birth Year (int 4)</a:t>
             </a:r>
           </a:p>
           <a:p>
@@ -40580,26 +40822,49 @@
               <a:buChar char="•"/>
             </a:pPr>
             <a:r>
-              <a:rPr sz="1100">
+              <a:rPr sz="900">
                 <a:solidFill>
                   <a:srgbClr val="FFFFFF"/>
                 </a:solidFill>
               </a:rPr>
-              <a:t>4 draft tables (TABL _D)</a:t>
-            </a:r>
-          </a:p>
-        </p:txBody>
-      </p:sp>
-      <p:sp>
-        <p:nvSpPr>
-          <p:cNvPr id="18" name="c_2_BlockGrid:1:c_6_Block"/>
+              <a:t>Biography (text)</a:t>
+            </a:r>
+          </a:p>
+          <a:p>
+            <a:pPr algn="l">
+              <a:spcAft>
+                <a:spcPts val="0"/>
+              </a:spcAft>
+            </a:pPr>
+            <a:r>
+              <a:rPr sz="1400" b="1">
+                <a:solidFill>
+                  <a:srgbClr val="FFFFFF"/>
+                </a:solidFill>
+              </a:rPr>
+              <a:t>Rule: </a:t>
+            </a:r>
+            <a:r>
+              <a:rPr sz="1400">
+                <a:solidFill>
+                  <a:srgbClr val="FFFFFF"/>
+                </a:solidFill>
+              </a:rPr>
+              <a:t>name unique; birth-year 1000..now.</a:t>
+            </a:r>
+          </a:p>
+        </p:txBody>
+      </p:sp>
+      <p:sp>
+        <p:nvSpPr>
+          <p:cNvPr id="6" name="c_1_BlockGrid:1:c_2_Block"/>
           <p:cNvSpPr/>
           <p:nvPr/>
         </p:nvSpPr>
         <p:spPr>
           <a:xfrm>
-            <a:off x="4206240" y="3200400"/>
-            <a:ext cx="3566160" cy="2926080"/>
+            <a:off x="3246120" y="1463040"/>
+            <a:ext cx="2697480" cy="4663440"/>
           </a:xfrm>
           <a:prstGeom prst="rect">
             <a:avLst/>
@@ -40645,12 +40910,27 @@
               </a:spcAft>
             </a:pPr>
             <a:r>
+              <a:rPr sz="1200" b="1">
+                <a:solidFill>
+                  <a:srgbClr val="FFFFFF"/>
+                </a:solidFill>
+              </a:rPr>
+              <a:t>Phase 2 · spec</a:t>
+            </a:r>
+          </a:p>
+          <a:p>
+            <a:pPr algn="l">
+              <a:spcAft>
+                <a:spcPts val="0"/>
+              </a:spcAft>
+            </a:pPr>
+            <a:r>
               <a:rPr sz="1400" b="1">
                 <a:solidFill>
                   <a:srgbClr val="FFFFFF"/>
                 </a:solidFill>
               </a:rPr>
-              <a:t>RAP layer</a:t>
+              <a:t>Table Z##_AUTHOR</a:t>
             </a:r>
           </a:p>
           <a:p>
@@ -40664,12 +40944,12 @@
               <a:buChar char="•"/>
             </a:pPr>
             <a:r>
-              <a:rPr sz="1100">
+              <a:rPr sz="900">
                 <a:solidFill>
                   <a:srgbClr val="FFFFFF"/>
                 </a:solidFill>
               </a:rPr>
-              <a:t>4 interface CDS (Z##_R_*)</a:t>
+              <a:t>author_id uuid · key</a:t>
             </a:r>
           </a:p>
           <a:p>
@@ -40683,12 +40963,12 @@
               <a:buChar char="•"/>
             </a:pPr>
             <a:r>
-              <a:rPr sz="1100">
+              <a:rPr sz="900">
                 <a:solidFill>
                   <a:srgbClr val="FFFFFF"/>
                 </a:solidFill>
               </a:rPr>
-              <a:t>4 projection CDS (Z##_C_*)</a:t>
+              <a:t>name z##_e_name (z##_d_name CHAR 100)</a:t>
             </a:r>
           </a:p>
           <a:p>
@@ -40702,12 +40982,12 @@
               <a:buChar char="•"/>
             </a:pPr>
             <a:r>
-              <a:rPr sz="1100">
+              <a:rPr sz="900">
                 <a:solidFill>
                   <a:srgbClr val="FFFFFF"/>
                 </a:solidFill>
               </a:rPr>
-              <a:t>4 metadata extensions</a:t>
+              <a:t>country z##_e_country</a:t>
             </a:r>
           </a:p>
           <a:p>
@@ -40721,26 +41001,220 @@
               <a:buChar char="•"/>
             </a:pPr>
             <a:r>
-              <a:rPr sz="1100">
+              <a:rPr sz="900">
                 <a:solidFill>
                   <a:srgbClr val="FFFFFF"/>
                 </a:solidFill>
               </a:rPr>
-              <a:t>4 BDEF + 4 BIMP classes</a:t>
-            </a:r>
-          </a:p>
-        </p:txBody>
-      </p:sp>
-      <p:sp>
-        <p:nvSpPr>
-          <p:cNvPr id="19" name="c_2_BlockGrid:2:c_7_Block"/>
+              <a:t>birth_year z##_e_year (NUMC 4)</a:t>
+            </a:r>
+          </a:p>
+          <a:p>
+            <a:pPr algn="l" marL="228600" indent="-182880">
+              <a:spcAft>
+                <a:spcPts val="0"/>
+              </a:spcAft>
+              <a:buClr>
+                <a:srgbClr val="FFFFFF"/>
+              </a:buClr>
+              <a:buChar char="•"/>
+            </a:pPr>
+            <a:r>
+              <a:rPr sz="900">
+                <a:solidFill>
+                  <a:srgbClr val="FFFFFF"/>
+                </a:solidFill>
+              </a:rPr>
+              <a:t>biography STRING</a:t>
+            </a:r>
+          </a:p>
+        </p:txBody>
+      </p:sp>
+      <p:sp>
+        <p:nvSpPr>
+          <p:cNvPr id="7" name="c_1_BlockGrid:2:c_3_Block"/>
           <p:cNvSpPr/>
           <p:nvPr/>
         </p:nvSpPr>
         <p:spPr>
           <a:xfrm>
-            <a:off x="7955280" y="3200400"/>
-            <a:ext cx="3566160" cy="2926080"/>
+            <a:off x="6035040" y="1463040"/>
+            <a:ext cx="2697480" cy="4663440"/>
+          </a:xfrm>
+          <a:prstGeom prst="rect">
+            <a:avLst/>
+          </a:prstGeom>
+          <a:gradFill rotWithShape="1">
+            <a:gsLst>
+              <a:gs pos="0">
+                <a:srgbClr val="CF12D3"/>
+              </a:gs>
+              <a:gs pos="100000">
+                <a:srgbClr val="E82BED"/>
+              </a:gs>
+            </a:gsLst>
+            <a:lin ang="16200000" scaled="0"/>
+          </a:gradFill>
+          <a:ln w="3175">
+            <a:solidFill>
+              <a:srgbClr val="644D64"/>
+            </a:solidFill>
+          </a:ln>
+        </p:spPr>
+        <p:style>
+          <a:lnRef idx="1">
+            <a:schemeClr val="accent1"/>
+          </a:lnRef>
+          <a:fillRef idx="3">
+            <a:schemeClr val="accent1"/>
+          </a:fillRef>
+          <a:effectRef idx="2">
+            <a:schemeClr val="accent1"/>
+          </a:effectRef>
+          <a:fontRef idx="minor">
+            <a:schemeClr val="lt1"/>
+          </a:fontRef>
+        </p:style>
+        <p:txBody>
+          <a:bodyPr rtlCol="0" anchor="t" wrap="square" tIns="91440" bIns="91440"/>
+          <a:lstStyle/>
+          <a:p>
+            <a:pPr algn="l">
+              <a:spcAft>
+                <a:spcPts val="500"/>
+              </a:spcAft>
+            </a:pPr>
+            <a:r>
+              <a:rPr sz="1200" b="1">
+                <a:solidFill>
+                  <a:srgbClr val="FFFFFF"/>
+                </a:solidFill>
+              </a:rPr>
+              <a:t>Phase 3 · plan</a:t>
+            </a:r>
+          </a:p>
+          <a:p>
+            <a:pPr algn="l">
+              <a:spcAft>
+                <a:spcPts val="0"/>
+              </a:spcAft>
+            </a:pPr>
+            <a:r>
+              <a:rPr sz="1400" b="1">
+                <a:solidFill>
+                  <a:srgbClr val="FFFFFF"/>
+                </a:solidFill>
+              </a:rPr>
+              <a:t>Step group · Author</a:t>
+            </a:r>
+          </a:p>
+          <a:p>
+            <a:pPr algn="l" marL="228600" indent="-182880">
+              <a:spcAft>
+                <a:spcPts val="0"/>
+              </a:spcAft>
+              <a:buClr>
+                <a:srgbClr val="FFFFFF"/>
+              </a:buClr>
+              <a:buChar char="•"/>
+            </a:pPr>
+            <a:r>
+              <a:rPr sz="900">
+                <a:solidFill>
+                  <a:srgbClr val="FFFFFF"/>
+                </a:solidFill>
+              </a:rPr>
+              <a:t>1.1 create 5 domains</a:t>
+            </a:r>
+          </a:p>
+          <a:p>
+            <a:pPr algn="l" marL="228600" indent="-182880">
+              <a:spcAft>
+                <a:spcPts val="0"/>
+              </a:spcAft>
+              <a:buClr>
+                <a:srgbClr val="FFFFFF"/>
+              </a:buClr>
+              <a:buChar char="•"/>
+            </a:pPr>
+            <a:r>
+              <a:rPr sz="900">
+                <a:solidFill>
+                  <a:srgbClr val="FFFFFF"/>
+                </a:solidFill>
+              </a:rPr>
+              <a:t>1.2 create 5 data elements</a:t>
+            </a:r>
+          </a:p>
+          <a:p>
+            <a:pPr algn="l" marL="228600" indent="-182880">
+              <a:spcAft>
+                <a:spcPts val="0"/>
+              </a:spcAft>
+              <a:buClr>
+                <a:srgbClr val="FFFFFF"/>
+              </a:buClr>
+              <a:buChar char="•"/>
+            </a:pPr>
+            <a:r>
+              <a:rPr sz="900">
+                <a:solidFill>
+                  <a:srgbClr val="FFFFFF"/>
+                </a:solidFill>
+              </a:rPr>
+              <a:t>2.1 create Z##_AUTHOR + draft</a:t>
+            </a:r>
+          </a:p>
+          <a:p>
+            <a:pPr algn="l" marL="228600" indent="-182880">
+              <a:spcAft>
+                <a:spcPts val="0"/>
+              </a:spcAft>
+              <a:buClr>
+                <a:srgbClr val="FFFFFF"/>
+              </a:buClr>
+              <a:buChar char="•"/>
+            </a:pPr>
+            <a:r>
+              <a:rPr sz="900">
+                <a:solidFill>
+                  <a:srgbClr val="FFFFFF"/>
+                </a:solidFill>
+              </a:rPr>
+              <a:t>3.1 CDS Z##_R_AUTHOR + C view</a:t>
+            </a:r>
+          </a:p>
+          <a:p>
+            <a:pPr algn="l" marL="228600" indent="-182880">
+              <a:spcAft>
+                <a:spcPts val="0"/>
+              </a:spcAft>
+              <a:buClr>
+                <a:srgbClr val="FFFFFF"/>
+              </a:buClr>
+              <a:buChar char="•"/>
+            </a:pPr>
+            <a:r>
+              <a:rPr sz="900">
+                <a:solidFill>
+                  <a:srgbClr val="FFFFFF"/>
+                </a:solidFill>
+              </a:rPr>
+              <a:t>4.1 BDEF + BIMP + activate</a:t>
+            </a:r>
+          </a:p>
+        </p:txBody>
+      </p:sp>
+      <p:sp>
+        <p:nvSpPr>
+          <p:cNvPr id="8" name="c_1_BlockGrid:3:c_4_Block"/>
+          <p:cNvSpPr/>
+          <p:nvPr/>
+        </p:nvSpPr>
+        <p:spPr>
+          <a:xfrm>
+            <a:off x="8823960" y="1463040"/>
+            <a:ext cx="2697480" cy="4663440"/>
           </a:xfrm>
           <a:prstGeom prst="rect">
             <a:avLst/>
@@ -40786,12 +41260,27 @@
               </a:spcAft>
             </a:pPr>
             <a:r>
+              <a:rPr sz="1200" b="1">
+                <a:solidFill>
+                  <a:srgbClr val="000000"/>
+                </a:solidFill>
+              </a:rPr>
+              <a:t>Phase 4 · objects</a:t>
+            </a:r>
+          </a:p>
+          <a:p>
+            <a:pPr algn="l">
+              <a:spcAft>
+                <a:spcPts val="0"/>
+              </a:spcAft>
+            </a:pPr>
+            <a:r>
               <a:rPr sz="1400" b="1">
                 <a:solidFill>
                   <a:srgbClr val="000000"/>
                 </a:solidFill>
               </a:rPr>
-              <a:t>Service · UI</a:t>
+              <a:t>Active on SAP</a:t>
             </a:r>
           </a:p>
           <a:p>
@@ -40805,12 +41294,12 @@
               <a:buChar char="•"/>
             </a:pPr>
             <a:r>
-              <a:rPr sz="1100">
+              <a:rPr sz="900">
                 <a:solidFill>
                   <a:srgbClr val="000000"/>
                 </a:solidFill>
               </a:rPr>
-              <a:t>1 service definition</a:t>
+              <a:t>DOMA · DTEL · 5+5</a:t>
             </a:r>
           </a:p>
           <a:p>
@@ -40824,12 +41313,12 @@
               <a:buChar char="•"/>
             </a:pPr>
             <a:r>
-              <a:rPr sz="1100">
+              <a:rPr sz="900">
                 <a:solidFill>
                   <a:srgbClr val="000000"/>
                 </a:solidFill>
               </a:rPr>
-              <a:t>1 OData V4 binding (published)</a:t>
+              <a:t>TABL Z##_AUTHOR + _D draft</a:t>
             </a:r>
           </a:p>
           <a:p>
@@ -40843,12 +41332,12 @@
               <a:buChar char="•"/>
             </a:pPr>
             <a:r>
-              <a:rPr sz="1100">
+              <a:rPr sz="900">
                 <a:solidFill>
                   <a:srgbClr val="000000"/>
                 </a:solidFill>
               </a:rPr>
-              <a:t>Fiori Elements preview · CRUD + draft</a:t>
+              <a:t>DDLS Z##_R_AUTHOR + C</a:t>
             </a:r>
           </a:p>
           <a:p>
@@ -40862,12 +41351,31 @@
               <a:buChar char="•"/>
             </a:pPr>
             <a:r>
-              <a:rPr sz="1100">
+              <a:rPr sz="900">
                 <a:solidFill>
                   <a:srgbClr val="000000"/>
                 </a:solidFill>
               </a:rPr>
-              <a:t>Author shows by name, not UUID</a:t>
+              <a:t>BDEF + BIMP class</a:t>
+            </a:r>
+          </a:p>
+          <a:p>
+            <a:pPr algn="l" marL="228600" indent="-182880">
+              <a:spcAft>
+                <a:spcPts val="0"/>
+              </a:spcAft>
+              <a:buClr>
+                <a:srgbClr val="000000"/>
+              </a:buClr>
+              <a:buChar char="•"/>
+            </a:pPr>
+            <a:r>
+              <a:rPr sz="900">
+                <a:solidFill>
+                  <a:srgbClr val="000000"/>
+                </a:solidFill>
+              </a:rPr>
+              <a:t>Service + binding</a:t>
             </a:r>
           </a:p>
         </p:txBody>

</xml_diff>

<commit_message>
docs(rap-deck): render the activating-objects skill as-is, not as cards
Previous version of the 'skill example' slide reformatted the file
content into two coloured cards — manager rightly called that out as
'наскальная пісьмєнность' (cave drawings). The whole point is to show
what an actual skill file looks like, so swap it for the verbatim text
of activating-objects.md in one block, small font, left-aligned.

Co-Authored-By: Claude Opus 4.7 (1M context) <noreply@anthropic.com>
</commit_message>
<xml_diff>
--- a/docs/tutorials/rap-bo-book-catalog/examples/book-catalog/report.simple-deck.pptx
+++ b/docs/tutorials/rap-bo-book-catalog/examples/book-catalog/report.simple-deck.pptx
@@ -40102,7 +40102,7 @@
           <a:lstStyle/>
           <a:p>
             <a:r>
-              <a:t>Skill example · activating-objects</a:t>
+              <a:t>Skill example · activating-objects.md</a:t>
             </a:r>
           </a:p>
         </p:txBody>
@@ -40123,7 +40123,7 @@
           <a:lstStyle/>
           <a:p>
             <a:r>
-              <a:t>41 LINES · ONE TASK</a:t>
+              <a:t>WHOLE FILE · AS-IS</a:t>
             </a:r>
           </a:p>
         </p:txBody>
@@ -40178,7 +40178,7 @@
         <p:spPr>
           <a:xfrm>
             <a:off x="457200" y="1463040"/>
-            <a:ext cx="11064240" cy="914400"/>
+            <a:ext cx="11064240" cy="4663440"/>
           </a:xfrm>
           <a:prstGeom prst="rect">
             <a:avLst/>
@@ -40224,36 +40224,12 @@
               </a:spcAft>
             </a:pPr>
             <a:r>
-              <a:rPr sz="1400" b="1">
+              <a:rPr sz="700">
                 <a:solidFill>
                   <a:srgbClr val="000000"/>
                 </a:solidFill>
               </a:rPr>
-              <a:t>name: </a:t>
-            </a:r>
-            <a:r>
-              <a:rPr sz="1400">
-                <a:solidFill>
-                  <a:srgbClr val="000000"/>
-                </a:solidFill>
-              </a:rPr>
-              <a:t>Activating Objects     </a:t>
-            </a:r>
-            <a:r>
-              <a:rPr sz="1400" b="1">
-                <a:solidFill>
-                  <a:srgbClr val="000000"/>
-                </a:solidFill>
-              </a:rPr>
-              <a:t>tags: </a:t>
-            </a:r>
-            <a:r>
-              <a:rPr sz="1400">
-                <a:solidFill>
-                  <a:srgbClr val="000000"/>
-                </a:solidFill>
-              </a:rPr>
-              <a:t>[sap, activation, governance]</a:t>
+              <a:t>name: Activating Objects</a:t>
             </a:r>
           </a:p>
           <a:p>
@@ -40263,245 +40239,12 @@
               </a:spcAft>
             </a:pPr>
             <a:r>
-              <a:rPr sz="1400" b="1">
+              <a:rPr sz="700">
                 <a:solidFill>
                   <a:srgbClr val="000000"/>
                 </a:solidFill>
               </a:rPr>
-              <a:t>description: </a:t>
-            </a:r>
-            <a:r>
-              <a:rPr sz="1400">
-                <a:solidFill>
-                  <a:srgbClr val="000000"/>
-                </a:solidFill>
-              </a:rPr>
-              <a:t>Rules for activating ABAP objects safely — never bare 'activate all', group activation for circular references, special tool for BDEF</a:t>
-            </a:r>
-          </a:p>
-        </p:txBody>
-      </p:sp>
-      <p:sp>
-        <p:nvSpPr>
-          <p:cNvPr id="6" name="c_1_BlockGrid:0:c_2_Block"/>
-          <p:cNvSpPr/>
-          <p:nvPr/>
-        </p:nvSpPr>
-        <p:spPr>
-          <a:xfrm>
-            <a:off x="457200" y="2514600"/>
-            <a:ext cx="5440680" cy="3611880"/>
-          </a:xfrm>
-          <a:prstGeom prst="rect">
-            <a:avLst/>
-          </a:prstGeom>
-          <a:gradFill rotWithShape="1">
-            <a:gsLst>
-              <a:gs pos="0">
-                <a:srgbClr val="CE0101"/>
-              </a:gs>
-              <a:gs pos="100000">
-                <a:srgbClr val="FC0606"/>
-              </a:gs>
-            </a:gsLst>
-            <a:lin ang="16200000" scaled="0"/>
-          </a:gradFill>
-          <a:ln w="3175">
-            <a:solidFill>
-              <a:srgbClr val="5D4545"/>
-            </a:solidFill>
-          </a:ln>
-        </p:spPr>
-        <p:style>
-          <a:lnRef idx="1">
-            <a:schemeClr val="accent1"/>
-          </a:lnRef>
-          <a:fillRef idx="3">
-            <a:schemeClr val="accent1"/>
-          </a:fillRef>
-          <a:effectRef idx="2">
-            <a:schemeClr val="accent1"/>
-          </a:effectRef>
-          <a:fontRef idx="minor">
-            <a:schemeClr val="lt1"/>
-          </a:fontRef>
-        </p:style>
-        <p:txBody>
-          <a:bodyPr rtlCol="0" anchor="t" wrap="square" tIns="91440" bIns="91440"/>
-          <a:lstStyle/>
-          <a:p>
-            <a:pPr algn="l">
-              <a:spcAft>
-                <a:spcPts val="500"/>
-              </a:spcAft>
-            </a:pPr>
-            <a:r>
-              <a:rPr sz="1200" b="1">
-                <a:solidFill>
-                  <a:srgbClr val="FFFFFF"/>
-                </a:solidFill>
-              </a:rPr>
-              <a:t>Hard rules</a:t>
-            </a:r>
-          </a:p>
-          <a:p>
-            <a:pPr algn="l" marL="228600" indent="-182880">
-              <a:spcAft>
-                <a:spcPts val="0"/>
-              </a:spcAft>
-              <a:buClr>
-                <a:srgbClr val="FFFFFF"/>
-              </a:buClr>
-              <a:buChar char="•"/>
-            </a:pPr>
-            <a:r>
-              <a:rPr sz="900">
-                <a:solidFill>
-                  <a:srgbClr val="FFFFFF"/>
-                </a:solidFill>
-              </a:rPr>
-              <a:t>Never bare 'activate all inactive' on a shared system — always filter by prefix Z##_.</a:t>
-            </a:r>
-          </a:p>
-          <a:p>
-            <a:pPr algn="l" marL="228600" indent="-182880">
-              <a:spcAft>
-                <a:spcPts val="0"/>
-              </a:spcAft>
-              <a:buClr>
-                <a:srgbClr val="FFFFFF"/>
-              </a:buClr>
-              <a:buChar char="•"/>
-            </a:pPr>
-            <a:r>
-              <a:rPr sz="900">
-                <a:solidFill>
-                  <a:srgbClr val="FFFFFF"/>
-                </a:solidFill>
-              </a:rPr>
-              <a:t>Syntax-check each object before activating; activation is expensive and partial failures cascade.</a:t>
-            </a:r>
-          </a:p>
-          <a:p>
-            <a:pPr algn="l" marL="228600" indent="-182880">
-              <a:spcAft>
-                <a:spcPts val="0"/>
-              </a:spcAft>
-              <a:buClr>
-                <a:srgbClr val="FFFFFF"/>
-              </a:buClr>
-              <a:buChar char="•"/>
-            </a:pPr>
-            <a:r>
-              <a:rPr sz="900">
-                <a:solidFill>
-                  <a:srgbClr val="FFFFFF"/>
-                </a:solidFill>
-              </a:rPr>
-              <a:t>Group activation for circular refs — CDS R views, CDS C views, BDEF + BIMP.</a:t>
-            </a:r>
-          </a:p>
-          <a:p>
-            <a:pPr algn="l" marL="228600" indent="-182880">
-              <a:spcAft>
-                <a:spcPts val="0"/>
-              </a:spcAft>
-              <a:buClr>
-                <a:srgbClr val="FFFFFF"/>
-              </a:buClr>
-              <a:buChar char="•"/>
-            </a:pPr>
-            <a:r>
-              <a:rPr sz="900">
-                <a:solidFill>
-                  <a:srgbClr val="FFFFFF"/>
-                </a:solidFill>
-              </a:rPr>
-              <a:t>BDEF: use ActivateBehaviorDefinition, not the generic ActivateObjects.</a:t>
-            </a:r>
-          </a:p>
-        </p:txBody>
-      </p:sp>
-      <p:sp>
-        <p:nvSpPr>
-          <p:cNvPr id="7" name="c_1_BlockGrid:1:c_3_Block"/>
-          <p:cNvSpPr/>
-          <p:nvPr/>
-        </p:nvSpPr>
-        <p:spPr>
-          <a:xfrm>
-            <a:off x="6080760" y="2514600"/>
-            <a:ext cx="5440680" cy="3611880"/>
-          </a:xfrm>
-          <a:prstGeom prst="rect">
-            <a:avLst/>
-          </a:prstGeom>
-          <a:gradFill rotWithShape="1">
-            <a:gsLst>
-              <a:gs pos="0">
-                <a:srgbClr val="C65F00"/>
-              </a:gs>
-              <a:gs pos="100000">
-                <a:srgbClr val="F97800"/>
-              </a:gs>
-            </a:gsLst>
-            <a:lin ang="16200000" scaled="0"/>
-          </a:gradFill>
-          <a:ln w="3175">
-            <a:solidFill>
-              <a:srgbClr val="5A4D42"/>
-            </a:solidFill>
-          </a:ln>
-        </p:spPr>
-        <p:style>
-          <a:lnRef idx="1">
-            <a:schemeClr val="accent1"/>
-          </a:lnRef>
-          <a:fillRef idx="3">
-            <a:schemeClr val="accent1"/>
-          </a:fillRef>
-          <a:effectRef idx="2">
-            <a:schemeClr val="accent1"/>
-          </a:effectRef>
-          <a:fontRef idx="minor">
-            <a:schemeClr val="lt1"/>
-          </a:fontRef>
-        </p:style>
-        <p:txBody>
-          <a:bodyPr rtlCol="0" anchor="t" wrap="square" tIns="91440" bIns="91440"/>
-          <a:lstStyle/>
-          <a:p>
-            <a:pPr algn="l">
-              <a:spcAft>
-                <a:spcPts val="500"/>
-              </a:spcAft>
-            </a:pPr>
-            <a:r>
-              <a:rPr sz="1200" b="1">
-                <a:solidFill>
-                  <a:srgbClr val="000000"/>
-                </a:solidFill>
-              </a:rPr>
-              <a:t>After + common errors</a:t>
-            </a:r>
-          </a:p>
-          <a:p>
-            <a:pPr algn="l" marL="228600" indent="-182880">
-              <a:spcAft>
-                <a:spcPts val="0"/>
-              </a:spcAft>
-              <a:buClr>
-                <a:srgbClr val="000000"/>
-              </a:buClr>
-              <a:buChar char="•"/>
-            </a:pPr>
-            <a:r>
-              <a:rPr sz="900">
-                <a:solidFill>
-                  <a:srgbClr val="000000"/>
-                </a:solidFill>
-              </a:rPr>
-              <a:t>After: re-syntax-check; Read… each object and confirm active: true.</a:t>
+              <a:t>description: Rules for activating ABAP objects safely — never bare "activate all",</a:t>
             </a:r>
           </a:p>
           <a:p>
@@ -40511,20 +40254,12 @@
               </a:spcAft>
             </a:pPr>
             <a:r>
-              <a:rPr sz="1400" b="1">
+              <a:rPr sz="700">
                 <a:solidFill>
                   <a:srgbClr val="000000"/>
                 </a:solidFill>
               </a:rPr>
-              <a:t>Activated unrelated objects → </a:t>
-            </a:r>
-            <a:r>
-              <a:rPr sz="1400">
-                <a:solidFill>
-                  <a:srgbClr val="000000"/>
-                </a:solidFill>
-              </a:rPr>
-              <a:t>missing prefix filter.</a:t>
+              <a:t>             group activation for circular references, special tool for BDEF.</a:t>
             </a:r>
           </a:p>
           <a:p>
@@ -40534,20 +40269,12 @@
               </a:spcAft>
             </a:pPr>
             <a:r>
-              <a:rPr sz="1400" b="1">
+              <a:rPr sz="700">
                 <a:solidFill>
                   <a:srgbClr val="000000"/>
                 </a:solidFill>
               </a:rPr>
-              <a:t>Still inactive after activate → </a:t>
-            </a:r>
-            <a:r>
-              <a:rPr sz="1400">
-                <a:solidFill>
-                  <a:srgbClr val="000000"/>
-                </a:solidFill>
-              </a:rPr>
-              <a:t>wrong tool (BDEF via ActivateObjects).</a:t>
+              <a:t>tags: [sap, activation, governance]</a:t>
             </a:r>
           </a:p>
           <a:p>
@@ -40557,20 +40284,387 @@
               </a:spcAft>
             </a:pPr>
             <a:r>
-              <a:rPr sz="1400" b="1">
+              <a:rPr sz="700">
                 <a:solidFill>
                   <a:srgbClr val="000000"/>
                 </a:solidFill>
               </a:rPr>
-              <a:t>Half-active layer → </a:t>
-            </a:r>
-            <a:r>
-              <a:rPr sz="1400">
+              <a:t> </a:t>
+            </a:r>
+          </a:p>
+          <a:p>
+            <a:pPr algn="l">
+              <a:spcAft>
+                <a:spcPts val="0"/>
+              </a:spcAft>
+            </a:pPr>
+            <a:r>
+              <a:rPr sz="700">
                 <a:solidFill>
                   <a:srgbClr val="000000"/>
                 </a:solidFill>
               </a:rPr>
-              <a:t>activated one-by-one; group-activate instead.</a:t>
+              <a:t># Activating Objects</a:t>
+            </a:r>
+          </a:p>
+          <a:p>
+            <a:pPr algn="l">
+              <a:spcAft>
+                <a:spcPts val="0"/>
+              </a:spcAft>
+            </a:pPr>
+            <a:r>
+              <a:rPr sz="700">
+                <a:solidFill>
+                  <a:srgbClr val="000000"/>
+                </a:solidFill>
+              </a:rPr>
+              <a:t> </a:t>
+            </a:r>
+          </a:p>
+          <a:p>
+            <a:pPr algn="l">
+              <a:spcAft>
+                <a:spcPts val="0"/>
+              </a:spcAft>
+            </a:pPr>
+            <a:r>
+              <a:rPr sz="700">
+                <a:solidFill>
+                  <a:srgbClr val="000000"/>
+                </a:solidFill>
+              </a:rPr>
+              <a:t>Activation locks objects and may fail partway through, leaving the system in an</a:t>
+            </a:r>
+          </a:p>
+          <a:p>
+            <a:pPr algn="l">
+              <a:spcAft>
+                <a:spcPts val="0"/>
+              </a:spcAft>
+            </a:pPr>
+            <a:r>
+              <a:rPr sz="700">
+                <a:solidFill>
+                  <a:srgbClr val="000000"/>
+                </a:solidFill>
+              </a:rPr>
+              <a:t>inconsistent state. The rules below are about safety and correctness, not speed.</a:t>
+            </a:r>
+          </a:p>
+          <a:p>
+            <a:pPr algn="l">
+              <a:spcAft>
+                <a:spcPts val="0"/>
+              </a:spcAft>
+            </a:pPr>
+            <a:r>
+              <a:rPr sz="700">
+                <a:solidFill>
+                  <a:srgbClr val="000000"/>
+                </a:solidFill>
+              </a:rPr>
+              <a:t> </a:t>
+            </a:r>
+          </a:p>
+          <a:p>
+            <a:pPr algn="l">
+              <a:spcAft>
+                <a:spcPts val="0"/>
+              </a:spcAft>
+            </a:pPr>
+            <a:r>
+              <a:rPr sz="700">
+                <a:solidFill>
+                  <a:srgbClr val="000000"/>
+                </a:solidFill>
+              </a:rPr>
+              <a:t>## Hard rules</a:t>
+            </a:r>
+          </a:p>
+          <a:p>
+            <a:pPr algn="l">
+              <a:spcAft>
+                <a:spcPts val="0"/>
+              </a:spcAft>
+            </a:pPr>
+            <a:r>
+              <a:rPr sz="700">
+                <a:solidFill>
+                  <a:srgbClr val="000000"/>
+                </a:solidFill>
+              </a:rPr>
+              <a:t> </a:t>
+            </a:r>
+          </a:p>
+          <a:p>
+            <a:pPr algn="l">
+              <a:spcAft>
+                <a:spcPts val="0"/>
+              </a:spcAft>
+            </a:pPr>
+            <a:r>
+              <a:rPr sz="700">
+                <a:solidFill>
+                  <a:srgbClr val="000000"/>
+                </a:solidFill>
+              </a:rPr>
+              <a:t>- Never run bare "Activate all inactive objects" on a shared system — filter by prefix Z##_.</a:t>
+            </a:r>
+          </a:p>
+          <a:p>
+            <a:pPr algn="l">
+              <a:spcAft>
+                <a:spcPts val="0"/>
+              </a:spcAft>
+            </a:pPr>
+            <a:r>
+              <a:rPr sz="700">
+                <a:solidFill>
+                  <a:srgbClr val="000000"/>
+                </a:solidFill>
+              </a:rPr>
+              <a:t>- Check before activating. Partial failures cascade; activation is expensive.</a:t>
+            </a:r>
+          </a:p>
+          <a:p>
+            <a:pPr algn="l">
+              <a:spcAft>
+                <a:spcPts val="0"/>
+              </a:spcAft>
+            </a:pPr>
+            <a:r>
+              <a:rPr sz="700">
+                <a:solidFill>
+                  <a:srgbClr val="000000"/>
+                </a:solidFill>
+              </a:rPr>
+              <a:t>- Group activation for circular references (CDS R-views, C-views). Create all,</a:t>
+            </a:r>
+          </a:p>
+          <a:p>
+            <a:pPr algn="l">
+              <a:spcAft>
+                <a:spcPts val="0"/>
+              </a:spcAft>
+            </a:pPr>
+            <a:r>
+              <a:rPr sz="700">
+                <a:solidFill>
+                  <a:srgbClr val="000000"/>
+                </a:solidFill>
+              </a:rPr>
+              <a:t>  activate together. Pre-activation "data source not active" errors disappear after.</a:t>
+            </a:r>
+          </a:p>
+          <a:p>
+            <a:pPr algn="l">
+              <a:spcAft>
+                <a:spcPts val="0"/>
+              </a:spcAft>
+            </a:pPr>
+            <a:r>
+              <a:rPr sz="700">
+                <a:solidFill>
+                  <a:srgbClr val="000000"/>
+                </a:solidFill>
+              </a:rPr>
+              <a:t>- BDEF + BIMP must be activated together — circular dependency.</a:t>
+            </a:r>
+          </a:p>
+          <a:p>
+            <a:pPr algn="l">
+              <a:spcAft>
+                <a:spcPts val="0"/>
+              </a:spcAft>
+            </a:pPr>
+            <a:r>
+              <a:rPr sz="700">
+                <a:solidFill>
+                  <a:srgbClr val="000000"/>
+                </a:solidFill>
+              </a:rPr>
+              <a:t>- BDEFs: call ActivateBehaviorDefinition. ActivateObjects is for DDIC and CDS.</a:t>
+            </a:r>
+          </a:p>
+          <a:p>
+            <a:pPr algn="l">
+              <a:spcAft>
+                <a:spcPts val="0"/>
+              </a:spcAft>
+            </a:pPr>
+            <a:r>
+              <a:rPr sz="700">
+                <a:solidFill>
+                  <a:srgbClr val="000000"/>
+                </a:solidFill>
+              </a:rPr>
+              <a:t> </a:t>
+            </a:r>
+          </a:p>
+          <a:p>
+            <a:pPr algn="l">
+              <a:spcAft>
+                <a:spcPts val="0"/>
+              </a:spcAft>
+            </a:pPr>
+            <a:r>
+              <a:rPr sz="700">
+                <a:solidFill>
+                  <a:srgbClr val="000000"/>
+                </a:solidFill>
+              </a:rPr>
+              <a:t>## After activation</a:t>
+            </a:r>
+          </a:p>
+          <a:p>
+            <a:pPr algn="l">
+              <a:spcAft>
+                <a:spcPts val="0"/>
+              </a:spcAft>
+            </a:pPr>
+            <a:r>
+              <a:rPr sz="700">
+                <a:solidFill>
+                  <a:srgbClr val="000000"/>
+                </a:solidFill>
+              </a:rPr>
+              <a:t> </a:t>
+            </a:r>
+          </a:p>
+          <a:p>
+            <a:pPr algn="l">
+              <a:spcAft>
+                <a:spcPts val="0"/>
+              </a:spcAft>
+            </a:pPr>
+            <a:r>
+              <a:rPr sz="700">
+                <a:solidFill>
+                  <a:srgbClr val="000000"/>
+                </a:solidFill>
+              </a:rPr>
+              <a:t>- Re-run syntax check on each object to surface warnings hidden by earlier errors.</a:t>
+            </a:r>
+          </a:p>
+          <a:p>
+            <a:pPr algn="l">
+              <a:spcAft>
+                <a:spcPts val="0"/>
+              </a:spcAft>
+            </a:pPr>
+            <a:r>
+              <a:rPr sz="700">
+                <a:solidFill>
+                  <a:srgbClr val="000000"/>
+                </a:solidFill>
+              </a:rPr>
+              <a:t>- Verify with Read… calls per object — response must include active: true.</a:t>
+            </a:r>
+          </a:p>
+          <a:p>
+            <a:pPr algn="l">
+              <a:spcAft>
+                <a:spcPts val="0"/>
+              </a:spcAft>
+            </a:pPr>
+            <a:r>
+              <a:rPr sz="700">
+                <a:solidFill>
+                  <a:srgbClr val="000000"/>
+                </a:solidFill>
+              </a:rPr>
+              <a:t> </a:t>
+            </a:r>
+          </a:p>
+          <a:p>
+            <a:pPr algn="l">
+              <a:spcAft>
+                <a:spcPts val="0"/>
+              </a:spcAft>
+            </a:pPr>
+            <a:r>
+              <a:rPr sz="700">
+                <a:solidFill>
+                  <a:srgbClr val="000000"/>
+                </a:solidFill>
+              </a:rPr>
+              <a:t>## Common error fix</a:t>
+            </a:r>
+          </a:p>
+          <a:p>
+            <a:pPr algn="l">
+              <a:spcAft>
+                <a:spcPts val="0"/>
+              </a:spcAft>
+            </a:pPr>
+            <a:r>
+              <a:rPr sz="700">
+                <a:solidFill>
+                  <a:srgbClr val="000000"/>
+                </a:solidFill>
+              </a:rPr>
+              <a:t> </a:t>
+            </a:r>
+          </a:p>
+          <a:p>
+            <a:pPr algn="l">
+              <a:spcAft>
+                <a:spcPts val="0"/>
+              </a:spcAft>
+            </a:pPr>
+            <a:r>
+              <a:rPr sz="700">
+                <a:solidFill>
+                  <a:srgbClr val="000000"/>
+                </a:solidFill>
+              </a:rPr>
+              <a:t>  Activated unrelated objects   → bare "activate all inactive"          → pass prefix filter</a:t>
+            </a:r>
+          </a:p>
+          <a:p>
+            <a:pPr algn="l">
+              <a:spcAft>
+                <a:spcPts val="0"/>
+              </a:spcAft>
+            </a:pPr>
+            <a:r>
+              <a:rPr sz="700">
+                <a:solidFill>
+                  <a:srgbClr val="000000"/>
+                </a:solidFill>
+              </a:rPr>
+              <a:t>  Still inactive after activate → BDEF via ActivateObjects               → use ActivateBehaviorDefinition</a:t>
+            </a:r>
+          </a:p>
+          <a:p>
+            <a:pPr algn="l">
+              <a:spcAft>
+                <a:spcPts val="0"/>
+              </a:spcAft>
+            </a:pPr>
+            <a:r>
+              <a:rPr sz="700">
+                <a:solidFill>
+                  <a:srgbClr val="000000"/>
+                </a:solidFill>
+              </a:rPr>
+              <a:t>  Half-active layer             → activated one-by-one (circular refs)   → group-activate whole layer</a:t>
+            </a:r>
+          </a:p>
+          <a:p>
+            <a:pPr algn="l">
+              <a:spcAft>
+                <a:spcPts val="0"/>
+              </a:spcAft>
+            </a:pPr>
+            <a:r>
+              <a:rPr sz="700">
+                <a:solidFill>
+                  <a:srgbClr val="000000"/>
+                </a:solidFill>
+              </a:rPr>
+              <a:t>  Syntax clean, activate fails  → prerequisite layer not active          → activate prerequisite first</a:t>
             </a:r>
           </a:p>
         </p:txBody>

</xml_diff>

<commit_message>
docs(rap-deck): skill-example slide — readable font + white background
Manager feedback: font 7 was unreadable, black-on-grey contrast bad.
Bumped to font 9, switched the block to SIMPLE style (no grey fill —
black-on-white). Trimmed the content to fit at the larger size.

Co-Authored-By: Claude Opus 4.7 (1M context) <noreply@anthropic.com>
</commit_message>
<xml_diff>
--- a/docs/tutorials/rap-bo-book-catalog/examples/book-catalog/report.simple-deck.pptx
+++ b/docs/tutorials/rap-bo-book-catalog/examples/book-catalog/report.simple-deck.pptx
@@ -40183,21 +40183,9 @@
           <a:prstGeom prst="rect">
             <a:avLst/>
           </a:prstGeom>
-          <a:gradFill rotWithShape="1">
-            <a:gsLst>
-              <a:gs pos="0">
-                <a:srgbClr val="7C7C7C"/>
-              </a:gs>
-              <a:gs pos="100000">
-                <a:srgbClr val="959595"/>
-              </a:gs>
-            </a:gsLst>
-            <a:lin ang="16200000" scaled="0"/>
-          </a:gradFill>
-          <a:ln w="3175">
-            <a:solidFill>
-              <a:srgbClr val="5F5F5F"/>
-            </a:solidFill>
+          <a:noFill/>
+          <a:ln>
+            <a:noFill/>
           </a:ln>
         </p:spPr>
         <p:style>
@@ -40215,7 +40203,7 @@
           </a:fontRef>
         </p:style>
         <p:txBody>
-          <a:bodyPr rtlCol="0" anchor="t" wrap="square" tIns="91440" bIns="91440"/>
+          <a:bodyPr rtlCol="0" anchor="t" wrap="square" lIns="45720" rIns="45720" tIns="36576" bIns="36576"/>
           <a:lstStyle/>
           <a:p>
             <a:pPr algn="l">
@@ -40224,7 +40212,7 @@
               </a:spcAft>
             </a:pPr>
             <a:r>
-              <a:rPr sz="700">
+              <a:rPr sz="900">
                 <a:solidFill>
                   <a:srgbClr val="000000"/>
                 </a:solidFill>
@@ -40239,12 +40227,12 @@
               </a:spcAft>
             </a:pPr>
             <a:r>
-              <a:rPr sz="700">
+              <a:rPr sz="900">
                 <a:solidFill>
                   <a:srgbClr val="000000"/>
                 </a:solidFill>
               </a:rPr>
-              <a:t>description: Rules for activating ABAP objects safely — never bare "activate all",</a:t>
+              <a:t>tags: [sap, activation, governance]</a:t>
             </a:r>
           </a:p>
           <a:p>
@@ -40254,12 +40242,12 @@
               </a:spcAft>
             </a:pPr>
             <a:r>
-              <a:rPr sz="700">
+              <a:rPr sz="900">
                 <a:solidFill>
                   <a:srgbClr val="000000"/>
                 </a:solidFill>
               </a:rPr>
-              <a:t>             group activation for circular references, special tool for BDEF.</a:t>
+              <a:t> </a:t>
             </a:r>
           </a:p>
           <a:p>
@@ -40269,12 +40257,12 @@
               </a:spcAft>
             </a:pPr>
             <a:r>
-              <a:rPr sz="700">
+              <a:rPr sz="900">
                 <a:solidFill>
                   <a:srgbClr val="000000"/>
                 </a:solidFill>
               </a:rPr>
-              <a:t>tags: [sap, activation, governance]</a:t>
+              <a:t># Activating Objects</a:t>
             </a:r>
           </a:p>
           <a:p>
@@ -40284,7 +40272,7 @@
               </a:spcAft>
             </a:pPr>
             <a:r>
-              <a:rPr sz="700">
+              <a:rPr sz="900">
                 <a:solidFill>
                   <a:srgbClr val="000000"/>
                 </a:solidFill>
@@ -40299,12 +40287,12 @@
               </a:spcAft>
             </a:pPr>
             <a:r>
-              <a:rPr sz="700">
+              <a:rPr sz="900">
                 <a:solidFill>
                   <a:srgbClr val="000000"/>
                 </a:solidFill>
               </a:rPr>
-              <a:t># Activating Objects</a:t>
+              <a:t>## Hard rules</a:t>
             </a:r>
           </a:p>
           <a:p>
@@ -40314,7 +40302,7 @@
               </a:spcAft>
             </a:pPr>
             <a:r>
-              <a:rPr sz="700">
+              <a:rPr sz="900">
                 <a:solidFill>
                   <a:srgbClr val="000000"/>
                 </a:solidFill>
@@ -40329,12 +40317,12 @@
               </a:spcAft>
             </a:pPr>
             <a:r>
-              <a:rPr sz="700">
+              <a:rPr sz="900">
                 <a:solidFill>
                   <a:srgbClr val="000000"/>
                 </a:solidFill>
               </a:rPr>
-              <a:t>Activation locks objects and may fail partway through, leaving the system in an</a:t>
+              <a:t>- Never bare "Activate all inactive objects" — filter by prefix Z##_.</a:t>
             </a:r>
           </a:p>
           <a:p>
@@ -40344,12 +40332,12 @@
               </a:spcAft>
             </a:pPr>
             <a:r>
-              <a:rPr sz="700">
+              <a:rPr sz="900">
                 <a:solidFill>
                   <a:srgbClr val="000000"/>
                 </a:solidFill>
               </a:rPr>
-              <a:t>inconsistent state. The rules below are about safety and correctness, not speed.</a:t>
+              <a:t>- Check before activating. Partial failures cascade.</a:t>
             </a:r>
           </a:p>
           <a:p>
@@ -40359,12 +40347,12 @@
               </a:spcAft>
             </a:pPr>
             <a:r>
-              <a:rPr sz="700">
+              <a:rPr sz="900">
                 <a:solidFill>
                   <a:srgbClr val="000000"/>
                 </a:solidFill>
               </a:rPr>
-              <a:t> </a:t>
+              <a:t>- Group activation for circular refs (CDS R-views, C-views).</a:t>
             </a:r>
           </a:p>
           <a:p>
@@ -40374,12 +40362,12 @@
               </a:spcAft>
             </a:pPr>
             <a:r>
-              <a:rPr sz="700">
+              <a:rPr sz="900">
                 <a:solidFill>
                   <a:srgbClr val="000000"/>
                 </a:solidFill>
               </a:rPr>
-              <a:t>## Hard rules</a:t>
+              <a:t>- BDEF + BIMP must be activated together.</a:t>
             </a:r>
           </a:p>
           <a:p>
@@ -40389,12 +40377,12 @@
               </a:spcAft>
             </a:pPr>
             <a:r>
-              <a:rPr sz="700">
+              <a:rPr sz="900">
                 <a:solidFill>
                   <a:srgbClr val="000000"/>
                 </a:solidFill>
               </a:rPr>
-              <a:t> </a:t>
+              <a:t>- BDEFs: ActivateBehaviorDefinition. ActivateObjects = DDIC + CDS only.</a:t>
             </a:r>
           </a:p>
           <a:p>
@@ -40404,12 +40392,12 @@
               </a:spcAft>
             </a:pPr>
             <a:r>
-              <a:rPr sz="700">
+              <a:rPr sz="900">
                 <a:solidFill>
                   <a:srgbClr val="000000"/>
                 </a:solidFill>
               </a:rPr>
-              <a:t>- Never run bare "Activate all inactive objects" on a shared system — filter by prefix Z##_.</a:t>
+              <a:t> </a:t>
             </a:r>
           </a:p>
           <a:p>
@@ -40419,12 +40407,12 @@
               </a:spcAft>
             </a:pPr>
             <a:r>
-              <a:rPr sz="700">
+              <a:rPr sz="900">
                 <a:solidFill>
                   <a:srgbClr val="000000"/>
                 </a:solidFill>
               </a:rPr>
-              <a:t>- Check before activating. Partial failures cascade; activation is expensive.</a:t>
+              <a:t>## After activation</a:t>
             </a:r>
           </a:p>
           <a:p>
@@ -40434,12 +40422,12 @@
               </a:spcAft>
             </a:pPr>
             <a:r>
-              <a:rPr sz="700">
+              <a:rPr sz="900">
                 <a:solidFill>
                   <a:srgbClr val="000000"/>
                 </a:solidFill>
               </a:rPr>
-              <a:t>- Group activation for circular references (CDS R-views, C-views). Create all,</a:t>
+              <a:t> </a:t>
             </a:r>
           </a:p>
           <a:p>
@@ -40449,12 +40437,12 @@
               </a:spcAft>
             </a:pPr>
             <a:r>
-              <a:rPr sz="700">
+              <a:rPr sz="900">
                 <a:solidFill>
                   <a:srgbClr val="000000"/>
                 </a:solidFill>
               </a:rPr>
-              <a:t>  activate together. Pre-activation "data source not active" errors disappear after.</a:t>
+              <a:t>- Re-run syntax check to surface warnings hidden by earlier errors.</a:t>
             </a:r>
           </a:p>
           <a:p>
@@ -40464,12 +40452,12 @@
               </a:spcAft>
             </a:pPr>
             <a:r>
-              <a:rPr sz="700">
+              <a:rPr sz="900">
                 <a:solidFill>
                   <a:srgbClr val="000000"/>
                 </a:solidFill>
               </a:rPr>
-              <a:t>- BDEF + BIMP must be activated together — circular dependency.</a:t>
+              <a:t>- Read… each object — response must include active: true.</a:t>
             </a:r>
           </a:p>
           <a:p>
@@ -40479,12 +40467,12 @@
               </a:spcAft>
             </a:pPr>
             <a:r>
-              <a:rPr sz="700">
+              <a:rPr sz="900">
                 <a:solidFill>
                   <a:srgbClr val="000000"/>
                 </a:solidFill>
               </a:rPr>
-              <a:t>- BDEFs: call ActivateBehaviorDefinition. ActivateObjects is for DDIC and CDS.</a:t>
+              <a:t> </a:t>
             </a:r>
           </a:p>
           <a:p>
@@ -40494,12 +40482,12 @@
               </a:spcAft>
             </a:pPr>
             <a:r>
-              <a:rPr sz="700">
+              <a:rPr sz="900">
                 <a:solidFill>
                   <a:srgbClr val="000000"/>
                 </a:solidFill>
               </a:rPr>
-              <a:t> </a:t>
+              <a:t>## Common error fix</a:t>
             </a:r>
           </a:p>
           <a:p>
@@ -40509,12 +40497,12 @@
               </a:spcAft>
             </a:pPr>
             <a:r>
-              <a:rPr sz="700">
+              <a:rPr sz="900">
                 <a:solidFill>
                   <a:srgbClr val="000000"/>
                 </a:solidFill>
               </a:rPr>
-              <a:t>## After activation</a:t>
+              <a:t> </a:t>
             </a:r>
           </a:p>
           <a:p>
@@ -40524,12 +40512,12 @@
               </a:spcAft>
             </a:pPr>
             <a:r>
-              <a:rPr sz="700">
+              <a:rPr sz="900">
                 <a:solidFill>
                   <a:srgbClr val="000000"/>
                 </a:solidFill>
               </a:rPr>
-              <a:t> </a:t>
+              <a:t>  Activated unrelated objects   → missing prefix filter</a:t>
             </a:r>
           </a:p>
           <a:p>
@@ -40539,12 +40527,12 @@
               </a:spcAft>
             </a:pPr>
             <a:r>
-              <a:rPr sz="700">
+              <a:rPr sz="900">
                 <a:solidFill>
                   <a:srgbClr val="000000"/>
                 </a:solidFill>
               </a:rPr>
-              <a:t>- Re-run syntax check on each object to surface warnings hidden by earlier errors.</a:t>
+              <a:t>  Still inactive after activate → wrong tool: use ActivateBehaviorDefinition</a:t>
             </a:r>
           </a:p>
           <a:p>
@@ -40554,12 +40542,12 @@
               </a:spcAft>
             </a:pPr>
             <a:r>
-              <a:rPr sz="700">
+              <a:rPr sz="900">
                 <a:solidFill>
                   <a:srgbClr val="000000"/>
                 </a:solidFill>
               </a:rPr>
-              <a:t>- Verify with Read… calls per object — response must include active: true.</a:t>
+              <a:t>  Half-active layer             → activated one-by-one; group-activate whole layer</a:t>
             </a:r>
           </a:p>
           <a:p>
@@ -40569,102 +40557,12 @@
               </a:spcAft>
             </a:pPr>
             <a:r>
-              <a:rPr sz="700">
+              <a:rPr sz="900">
                 <a:solidFill>
                   <a:srgbClr val="000000"/>
                 </a:solidFill>
               </a:rPr>
-              <a:t> </a:t>
-            </a:r>
-          </a:p>
-          <a:p>
-            <a:pPr algn="l">
-              <a:spcAft>
-                <a:spcPts val="0"/>
-              </a:spcAft>
-            </a:pPr>
-            <a:r>
-              <a:rPr sz="700">
-                <a:solidFill>
-                  <a:srgbClr val="000000"/>
-                </a:solidFill>
-              </a:rPr>
-              <a:t>## Common error fix</a:t>
-            </a:r>
-          </a:p>
-          <a:p>
-            <a:pPr algn="l">
-              <a:spcAft>
-                <a:spcPts val="0"/>
-              </a:spcAft>
-            </a:pPr>
-            <a:r>
-              <a:rPr sz="700">
-                <a:solidFill>
-                  <a:srgbClr val="000000"/>
-                </a:solidFill>
-              </a:rPr>
-              <a:t> </a:t>
-            </a:r>
-          </a:p>
-          <a:p>
-            <a:pPr algn="l">
-              <a:spcAft>
-                <a:spcPts val="0"/>
-              </a:spcAft>
-            </a:pPr>
-            <a:r>
-              <a:rPr sz="700">
-                <a:solidFill>
-                  <a:srgbClr val="000000"/>
-                </a:solidFill>
-              </a:rPr>
-              <a:t>  Activated unrelated objects   → bare "activate all inactive"          → pass prefix filter</a:t>
-            </a:r>
-          </a:p>
-          <a:p>
-            <a:pPr algn="l">
-              <a:spcAft>
-                <a:spcPts val="0"/>
-              </a:spcAft>
-            </a:pPr>
-            <a:r>
-              <a:rPr sz="700">
-                <a:solidFill>
-                  <a:srgbClr val="000000"/>
-                </a:solidFill>
-              </a:rPr>
-              <a:t>  Still inactive after activate → BDEF via ActivateObjects               → use ActivateBehaviorDefinition</a:t>
-            </a:r>
-          </a:p>
-          <a:p>
-            <a:pPr algn="l">
-              <a:spcAft>
-                <a:spcPts val="0"/>
-              </a:spcAft>
-            </a:pPr>
-            <a:r>
-              <a:rPr sz="700">
-                <a:solidFill>
-                  <a:srgbClr val="000000"/>
-                </a:solidFill>
-              </a:rPr>
-              <a:t>  Half-active layer             → activated one-by-one (circular refs)   → group-activate whole layer</a:t>
-            </a:r>
-          </a:p>
-          <a:p>
-            <a:pPr algn="l">
-              <a:spcAft>
-                <a:spcPts val="0"/>
-              </a:spcAft>
-            </a:pPr>
-            <a:r>
-              <a:rPr sz="700">
-                <a:solidFill>
-                  <a:srgbClr val="000000"/>
-                </a:solidFill>
-              </a:rPr>
-              <a:t>  Syntax clean, activate fails  → prerequisite layer not active          → activate prerequisite first</a:t>
+              <a:t>  Syntax clean, activate fails  → prerequisite layer not active</a:t>
             </a:r>
           </a:p>
         </p:txBody>

</xml_diff>